<commit_message>
Remove the progress and conclusion slides from the final review deck
"Progress Since the Last Review" and "Conclusion — Where the Project Stands"
are gone. The outline on slide 2 listed a Conclusion section, so that entry is
removed and the list renumbered to nine; leaving it would have promised a
slide the deck no longer has.

The conclusion slide also carried "Nothing reaches the block threshold", which
the September measurement contradicts. The surviving statement of that result
is on slide 20, which already says 25 fraudulent transactions reach it.
26 slides to 24.

Co-Authored-By: Claude Opus 5 <noreply@anthropic.com>
</commit_message>
<xml_diff>
--- a/docs/Indus11-Final-Review.pptx
+++ b/docs/Indus11-Final-Review.pptx
@@ -31,9 +31,7 @@
     <p:sldId id="285" r:id="rId37"/>
     <p:sldId id="286" r:id="rId38"/>
     <p:sldId id="269" r:id="rId19"/>
-    <p:sldId id="270" r:id="rId20"/>
     <p:sldId id="265" r:id="rId21"/>
-    <p:sldId id="266" r:id="rId22"/>
     <p:sldId id="267" r:id="rId23"/>
     <p:sldId id="271" r:id="rId24"/>
     <p:sldId id="268" r:id="rId25"/>
@@ -5675,7 +5673,7 @@
 </p:sld>
 </file>
 
-<file path=ppt/slides/slide17.xml><?xml version="1.0" encoding="utf-8"?>
+<file path=ppt/slides/slide12.xml><?xml version="1.0" encoding="utf-8"?>
 <p:sld xmlns:a="http://schemas.openxmlformats.org/drawingml/2006/main" xmlns:r="http://schemas.openxmlformats.org/officeDocument/2006/relationships" xmlns:p="http://schemas.openxmlformats.org/presentationml/2006/main">
   <p:cSld>
     <p:spTree>
@@ -6438,7 +6436,7 @@
 </p:sld>
 </file>
 
-<file path=ppt/slides/slide18.xml><?xml version="1.0" encoding="utf-8"?>
+<file path=ppt/slides/slide13.xml><?xml version="1.0" encoding="utf-8"?>
 <p:sld xmlns:a="http://schemas.openxmlformats.org/drawingml/2006/main" xmlns:r="http://schemas.openxmlformats.org/officeDocument/2006/relationships" xmlns:p="http://schemas.openxmlformats.org/presentationml/2006/main">
   <p:cSld>
     <p:spTree>
@@ -6821,7 +6819,7 @@
 </p:sld>
 </file>
 
-<file path=ppt/slides/slide19.xml><?xml version="1.0" encoding="utf-8"?>
+<file path=ppt/slides/slide14.xml><?xml version="1.0" encoding="utf-8"?>
 <p:sld xmlns:a="http://schemas.openxmlformats.org/drawingml/2006/main" xmlns:r="http://schemas.openxmlformats.org/officeDocument/2006/relationships" xmlns:p="http://schemas.openxmlformats.org/presentationml/2006/main">
   <p:cSld>
     <p:spTree>
@@ -7750,287 +7748,7 @@
 </p:sld>
 </file>
 
-<file path=ppt/slides/slide2.xml><?xml version="1.0" encoding="utf-8"?>
-<p:sld xmlns:a="http://schemas.openxmlformats.org/drawingml/2006/main" xmlns:r="http://schemas.openxmlformats.org/officeDocument/2006/relationships" xmlns:p="http://schemas.openxmlformats.org/presentationml/2006/main">
-  <p:cSld>
-    <p:spTree>
-      <p:nvGrpSpPr>
-        <p:cNvPr id="1" name=""/>
-        <p:cNvGrpSpPr/>
-        <p:nvPr/>
-      </p:nvGrpSpPr>
-      <p:grpSpPr>
-        <a:xfrm>
-          <a:off x="0" y="0"/>
-          <a:ext cx="0" cy="0"/>
-          <a:chOff x="0" y="0"/>
-          <a:chExt cx="0" cy="0"/>
-        </a:xfrm>
-      </p:grpSpPr>
-      <p:sp>
-        <p:nvSpPr>
-          <p:cNvPr id="2" name="Title 1">
-            <a:extLst>
-              <a:ext uri="{FF2B5EF4-FFF2-40B4-BE49-F238E27FC236}">
-                <a16:creationId xmlns:a16="http://schemas.microsoft.com/office/drawing/2014/main" id="{5E288B20-417E-44A5-9E46-172FDC9DC3BA}"/>
-              </a:ext>
-            </a:extLst>
-          </p:cNvPr>
-          <p:cNvSpPr>
-            <a:spLocks noGrp="1"/>
-          </p:cNvSpPr>
-          <p:nvPr>
-            <p:ph type="title"/>
-          </p:nvPr>
-        </p:nvSpPr>
-        <p:spPr>
-          <a:xfrm>
-            <a:off x="8703" y="420580"/>
-            <a:ext cx="9880984" cy="791568"/>
-          </a:xfrm>
-        </p:spPr>
-        <p:txBody>
-          <a:bodyPr>
-            <a:normAutofit/>
-          </a:bodyPr>
-          <a:lstStyle/>
-          <a:p>
-            <a:r>
-              <a:rPr sz="2800" b="1">
-                <a:solidFill>
-                  <a:srgbClr val="002060"/>
-                </a:solidFill>
-                <a:latin typeface="Cambria"/>
-              </a:rPr>
-              <a:t>Outline of Presentation</a:t>
-            </a:r>
-          </a:p>
-        </p:txBody>
-      </p:sp>
-      <p:sp>
-        <p:nvSpPr>
-          <p:cNvPr id="7" name="Slide Number Placeholder 6">
-            <a:extLst>
-              <a:ext uri="{FF2B5EF4-FFF2-40B4-BE49-F238E27FC236}">
-                <a16:creationId xmlns:a16="http://schemas.microsoft.com/office/drawing/2014/main" id="{939229BD-8564-4A52-83BC-42D34CF41294}"/>
-              </a:ext>
-            </a:extLst>
-          </p:cNvPr>
-          <p:cNvSpPr>
-            <a:spLocks noGrp="1"/>
-          </p:cNvSpPr>
-          <p:nvPr>
-            <p:ph type="sldNum" sz="quarter" idx="12"/>
-          </p:nvPr>
-        </p:nvSpPr>
-        <p:spPr/>
-        <p:txBody>
-          <a:bodyPr/>
-          <a:lstStyle/>
-          <a:p>
-            <a:fld id="{AEC92F7B-3D78-491F-9E9D-356A40665CCC}" type="slidenum">
-              <a:rPr lang="en-IN" smtClean="0"/>
-              <a:t>2</a:t>
-            </a:fld>
-            <a:endParaRPr lang="en-IN" dirty="0"/>
-          </a:p>
-        </p:txBody>
-      </p:sp>
-      <p:sp>
-        <p:nvSpPr>
-          <p:cNvPr id="3" name="Rectangle 2">
-            <a:extLst>
-              <a:ext uri="{FF2B5EF4-FFF2-40B4-BE49-F238E27FC236}">
-                <a16:creationId xmlns:a16="http://schemas.microsoft.com/office/drawing/2014/main" id="{E59BD91F-2C4F-5429-F6E6-7C065ACACBC1}"/>
-              </a:ext>
-            </a:extLst>
-          </p:cNvPr>
-          <p:cNvSpPr/>
-          <p:nvPr/>
-        </p:nvSpPr>
-        <p:spPr>
-          <a:xfrm>
-            <a:off x="47309" y="1266921"/>
-            <a:ext cx="12070080" cy="5638800"/>
-          </a:xfrm>
-          <a:prstGeom prst="rect">
-            <a:avLst/>
-          </a:prstGeom>
-        </p:spPr>
-        <p:txBody>
-          <a:bodyPr wrap="square" anchor="t"/>
-          <a:lstStyle/>
-          <a:p>
-            <a:pPr lvl="0" algn="l">
-              <a:spcAft>
-                <a:spcPts val="1000"/>
-              </a:spcAft>
-            </a:pPr>
-            <a:r>
-              <a:rPr sz="2000" b="0" dirty="0">
-                <a:solidFill>
-                  <a:srgbClr val="222833"/>
-                </a:solidFill>
-                <a:latin typeface="Cambria"/>
-              </a:rPr>
-              <a:t>1.  Review Comments &amp; Actions (Proposal · Review 1 · Mid-Semester)</a:t>
-            </a:r>
-          </a:p>
-          <a:p>
-            <a:pPr>
-              <a:spcAft>
-                <a:spcPts val="1000"/>
-              </a:spcAft>
-            </a:pPr>
-            <a:r>
-              <a:rPr sz="2000" b="0" dirty="0">
-                <a:solidFill>
-                  <a:srgbClr val="222833"/>
-                </a:solidFill>
-                <a:latin typeface="Cambria"/>
-              </a:rPr>
-              <a:t>2.  Problem Statement &amp; Objectives</a:t>
-            </a:r>
-          </a:p>
-          <a:p>
-            <a:pPr>
-              <a:spcAft>
-                <a:spcPts val="1000"/>
-              </a:spcAft>
-            </a:pPr>
-            <a:r>
-              <a:rPr sz="2000" b="0" dirty="0">
-                <a:solidFill>
-                  <a:srgbClr val="222833"/>
-                </a:solidFill>
-                <a:latin typeface="Cambria"/>
-              </a:rPr>
-              <a:t>3.  System Architecture</a:t>
-            </a:r>
-          </a:p>
-          <a:p>
-            <a:pPr>
-              <a:spcAft>
-                <a:spcPts val="1000"/>
-              </a:spcAft>
-            </a:pPr>
-            <a:r>
-              <a:rPr sz="2000" b="0" dirty="0">
-                <a:solidFill>
-                  <a:srgbClr val="222833"/>
-                </a:solidFill>
-                <a:latin typeface="Cambria"/>
-              </a:rPr>
-              <a:t>4.  Process Flow / Data-Flow Diagram (DFD)</a:t>
-            </a:r>
-          </a:p>
-          <a:p>
-            <a:pPr>
-              <a:spcAft>
-                <a:spcPts val="1000"/>
-              </a:spcAft>
-            </a:pPr>
-            <a:r>
-              <a:rPr sz="2000" b="0" dirty="0">
-                <a:solidFill>
-                  <a:srgbClr val="222833"/>
-                </a:solidFill>
-                <a:latin typeface="Cambria"/>
-              </a:rPr>
-              <a:t>5.  Literature Review &amp; Existing Solutions</a:t>
-            </a:r>
-          </a:p>
-          <a:p>
-            <a:pPr>
-              <a:spcAft>
-                <a:spcPts val="1000"/>
-              </a:spcAft>
-            </a:pPr>
-            <a:r>
-              <a:rPr sz="2000" b="0" dirty="0">
-                <a:solidFill>
-                  <a:srgbClr val="222833"/>
-                </a:solidFill>
-                <a:latin typeface="Cambria"/>
-              </a:rPr>
-              <a:t>6.  Implementation Progress (Screenshots + Code)</a:t>
-            </a:r>
-          </a:p>
-          <a:p>
-            <a:pPr>
-              <a:spcAft>
-                <a:spcPts val="1000"/>
-              </a:spcAft>
-            </a:pPr>
-            <a:r>
-              <a:rPr sz="2000" b="0" dirty="0">
-                <a:solidFill>
-                  <a:srgbClr val="222833"/>
-                </a:solidFill>
-                <a:latin typeface="Cambria"/>
-              </a:rPr>
-              <a:t>7.  Challenges Faced &amp; Future Work</a:t>
-            </a:r>
-          </a:p>
-          <a:p>
-            <a:pPr>
-              <a:spcAft>
-                <a:spcPts val="1000"/>
-              </a:spcAft>
-            </a:pPr>
-            <a:r>
-              <a:rPr sz="2000" b="0" dirty="0">
-                <a:solidFill>
-                  <a:srgbClr val="222833"/>
-                </a:solidFill>
-                <a:latin typeface="Cambria"/>
-              </a:rPr>
-              <a:t>8.  Conclusion</a:t>
-            </a:r>
-          </a:p>
-          <a:p>
-            <a:pPr>
-              <a:spcAft>
-                <a:spcPts val="1000"/>
-              </a:spcAft>
-            </a:pPr>
-            <a:r>
-              <a:rPr sz="2000" b="0" dirty="0">
-                <a:solidFill>
-                  <a:srgbClr val="222833"/>
-                </a:solidFill>
-                <a:latin typeface="Cambria"/>
-              </a:rPr>
-              <a:t>9.  References</a:t>
-            </a:r>
-          </a:p>
-          <a:p>
-            <a:r>
-              <a:rPr sz="2000" b="0" dirty="0">
-                <a:solidFill>
-                  <a:srgbClr val="222833"/>
-                </a:solidFill>
-                <a:latin typeface="Cambria"/>
-              </a:rPr>
-              <a:t>10.  Team Contributions</a:t>
-            </a:r>
-          </a:p>
-        </p:txBody>
-      </p:sp>
-    </p:spTree>
-    <p:extLst>
-      <p:ext uri="{BB962C8B-B14F-4D97-AF65-F5344CB8AC3E}">
-        <p14:creationId xmlns:p14="http://schemas.microsoft.com/office/powerpoint/2010/main" val="866290265"/>
-      </p:ext>
-    </p:extLst>
-  </p:cSld>
-  <p:clrMapOvr>
-    <a:masterClrMapping/>
-  </p:clrMapOvr>
-</p:sld>
-</file>
-
-<file path=ppt/slides/slide20.xml><?xml version="1.0" encoding="utf-8"?>
+<file path=ppt/slides/slide15.xml><?xml version="1.0" encoding="utf-8"?>
 <p:sld xmlns:a="http://schemas.openxmlformats.org/drawingml/2006/main" xmlns:p="http://schemas.openxmlformats.org/presentationml/2006/main" xmlns:r="http://schemas.openxmlformats.org/officeDocument/2006/relationships">
   <p:cSld>
     <p:spTree>
@@ -8173,7 +7891,7 @@
 </p:sld>
 </file>
 
-<file path=ppt/slides/slide21.xml><?xml version="1.0" encoding="utf-8"?>
+<file path=ppt/slides/slide16.xml><?xml version="1.0" encoding="utf-8"?>
 <p:sld xmlns:a="http://schemas.openxmlformats.org/drawingml/2006/main" xmlns:p="http://schemas.openxmlformats.org/presentationml/2006/main" xmlns:r="http://schemas.openxmlformats.org/officeDocument/2006/relationships">
   <p:cSld>
     <p:spTree>
@@ -8316,7 +8034,7 @@
 </p:sld>
 </file>
 
-<file path=ppt/slides/slide22.xml><?xml version="1.0" encoding="utf-8"?>
+<file path=ppt/slides/slide17.xml><?xml version="1.0" encoding="utf-8"?>
 <p:sld xmlns:a="http://schemas.openxmlformats.org/drawingml/2006/main" xmlns:p="http://schemas.openxmlformats.org/presentationml/2006/main" xmlns:r="http://schemas.openxmlformats.org/officeDocument/2006/relationships">
   <p:cSld>
     <p:spTree>
@@ -8459,7 +8177,7 @@
 </p:sld>
 </file>
 
-<file path=ppt/slides/slide23.xml><?xml version="1.0" encoding="utf-8"?>
+<file path=ppt/slides/slide18.xml><?xml version="1.0" encoding="utf-8"?>
 <p:sld xmlns:a="http://schemas.openxmlformats.org/drawingml/2006/main" xmlns:p="http://schemas.openxmlformats.org/presentationml/2006/main" xmlns:r="http://schemas.openxmlformats.org/officeDocument/2006/relationships">
   <p:cSld>
     <p:spTree>
@@ -8602,7 +8320,7 @@
 </p:sld>
 </file>
 
-<file path=ppt/slides/slide24.xml><?xml version="1.0" encoding="utf-8"?>
+<file path=ppt/slides/slide19.xml><?xml version="1.0" encoding="utf-8"?>
 <p:sld xmlns:a="http://schemas.openxmlformats.org/drawingml/2006/main" xmlns:p="http://schemas.openxmlformats.org/presentationml/2006/main" xmlns:r="http://schemas.openxmlformats.org/officeDocument/2006/relationships">
   <p:cSld>
     <p:spTree>
@@ -8745,7 +8463,236 @@
 </p:sld>
 </file>
 
-<file path=ppt/slides/slide25.xml><?xml version="1.0" encoding="utf-8"?>
+<file path=ppt/slides/slide2.xml><?xml version="1.0" encoding="utf-8"?>
+<p:sld xmlns:a="http://schemas.openxmlformats.org/drawingml/2006/main" xmlns:r="http://schemas.openxmlformats.org/officeDocument/2006/relationships" xmlns:p="http://schemas.openxmlformats.org/presentationml/2006/main">
+  <p:cSld>
+    <p:spTree>
+      <p:nvGrpSpPr>
+        <p:cNvPr id="1" name=""/>
+        <p:cNvGrpSpPr/>
+        <p:nvPr/>
+      </p:nvGrpSpPr>
+      <p:grpSpPr>
+        <a:xfrm>
+          <a:off x="0" y="0"/>
+          <a:ext cx="0" cy="0"/>
+          <a:chOff x="0" y="0"/>
+          <a:chExt cx="0" cy="0"/>
+        </a:xfrm>
+      </p:grpSpPr>
+      <p:sp>
+        <p:nvSpPr>
+          <p:cNvPr id="2" name="Title 1">
+            <a:extLst>
+              <a:ext uri="{FF2B5EF4-FFF2-40B4-BE49-F238E27FC236}">
+                <a16:creationId xmlns:a16="http://schemas.microsoft.com/office/drawing/2014/main" id="{5E288B20-417E-44A5-9E46-172FDC9DC3BA}"/>
+              </a:ext>
+            </a:extLst>
+          </p:cNvPr>
+          <p:cNvSpPr>
+            <a:spLocks noGrp="1"/>
+          </p:cNvSpPr>
+          <p:nvPr>
+            <p:ph type="title"/>
+          </p:nvPr>
+        </p:nvSpPr>
+        <p:spPr>
+          <a:xfrm>
+            <a:off x="8703" y="420580"/>
+            <a:ext cx="9880984" cy="791568"/>
+          </a:xfrm>
+        </p:spPr>
+        <p:txBody>
+          <a:bodyPr>
+            <a:normAutofit/>
+          </a:bodyPr>
+          <a:lstStyle/>
+          <a:p>
+            <a:r>
+              <a:rPr sz="2800" b="1">
+                <a:solidFill>
+                  <a:srgbClr val="002060"/>
+                </a:solidFill>
+                <a:latin typeface="Cambria"/>
+              </a:rPr>
+              <a:t>Outline of Presentation</a:t>
+            </a:r>
+          </a:p>
+        </p:txBody>
+      </p:sp>
+      <p:sp>
+        <p:nvSpPr>
+          <p:cNvPr id="7" name="Slide Number Placeholder 6">
+            <a:extLst>
+              <a:ext uri="{FF2B5EF4-FFF2-40B4-BE49-F238E27FC236}">
+                <a16:creationId xmlns:a16="http://schemas.microsoft.com/office/drawing/2014/main" id="{939229BD-8564-4A52-83BC-42D34CF41294}"/>
+              </a:ext>
+            </a:extLst>
+          </p:cNvPr>
+          <p:cNvSpPr>
+            <a:spLocks noGrp="1"/>
+          </p:cNvSpPr>
+          <p:nvPr>
+            <p:ph type="sldNum" sz="quarter" idx="12"/>
+          </p:nvPr>
+        </p:nvSpPr>
+        <p:spPr/>
+        <p:txBody>
+          <a:bodyPr/>
+          <a:lstStyle/>
+          <a:p>
+            <a:fld id="{AEC92F7B-3D78-491F-9E9D-356A40665CCC}" type="slidenum">
+              <a:rPr lang="en-IN" smtClean="0"/>
+              <a:t>2</a:t>
+            </a:fld>
+            <a:endParaRPr lang="en-IN" dirty="0"/>
+          </a:p>
+        </p:txBody>
+      </p:sp>
+      <p:sp>
+        <p:nvSpPr>
+          <p:cNvPr id="3" name="Rectangle 2">
+            <a:extLst>
+              <a:ext uri="{FF2B5EF4-FFF2-40B4-BE49-F238E27FC236}">
+                <a16:creationId xmlns:a16="http://schemas.microsoft.com/office/drawing/2014/main" id="{E59BD91F-2C4F-5429-F6E6-7C065ACACBC1}"/>
+              </a:ext>
+            </a:extLst>
+          </p:cNvPr>
+          <p:cNvSpPr/>
+          <p:nvPr/>
+        </p:nvSpPr>
+        <p:spPr>
+          <a:xfrm>
+            <a:off x="47309" y="1266921"/>
+            <a:ext cx="12070080" cy="5638800"/>
+          </a:xfrm>
+          <a:prstGeom prst="rect">
+            <a:avLst/>
+          </a:prstGeom>
+        </p:spPr>
+        <p:txBody>
+          <a:bodyPr wrap="square" anchor="t"/>
+          <a:lstStyle/>
+          <a:p>
+            <a:pPr lvl="0" algn="l">
+              <a:spcAft>
+                <a:spcPts val="1000"/>
+              </a:spcAft>
+            </a:pPr>
+            <a:r>
+              <a:rPr sz="2000">
+                <a:solidFill>
+                  <a:srgbClr val="222833"/>
+                </a:solidFill>
+                <a:latin typeface="Cambria"/>
+              </a:rPr>
+              <a:t>1.  Review Comments &amp; Actions (Proposal · Review 1 · Mid-Semester)</a:t>
+            </a:r>
+          </a:p>
+          <a:p>
+            <a:r>
+              <a:rPr sz="2000">
+                <a:solidFill>
+                  <a:srgbClr val="222833"/>
+                </a:solidFill>
+                <a:latin typeface="Cambria"/>
+              </a:rPr>
+              <a:t>2.  Problem Statement &amp; Objectives</a:t>
+            </a:r>
+          </a:p>
+          <a:p>
+            <a:r>
+              <a:rPr sz="2000">
+                <a:solidFill>
+                  <a:srgbClr val="222833"/>
+                </a:solidFill>
+                <a:latin typeface="Cambria"/>
+              </a:rPr>
+              <a:t>3.  System Architecture</a:t>
+            </a:r>
+          </a:p>
+          <a:p>
+            <a:r>
+              <a:rPr sz="2000">
+                <a:solidFill>
+                  <a:srgbClr val="222833"/>
+                </a:solidFill>
+                <a:latin typeface="Cambria"/>
+              </a:rPr>
+              <a:t>4.  Process Flow / Data-Flow Diagram (DFD)</a:t>
+            </a:r>
+          </a:p>
+          <a:p>
+            <a:r>
+              <a:rPr sz="2000">
+                <a:solidFill>
+                  <a:srgbClr val="222833"/>
+                </a:solidFill>
+                <a:latin typeface="Cambria"/>
+              </a:rPr>
+              <a:t>5.  Literature Review &amp; Existing Solutions</a:t>
+            </a:r>
+          </a:p>
+          <a:p>
+            <a:r>
+              <a:rPr sz="2000">
+                <a:solidFill>
+                  <a:srgbClr val="222833"/>
+                </a:solidFill>
+                <a:latin typeface="Cambria"/>
+              </a:rPr>
+              <a:t>6.  Implementation Progress (Screenshots + Code)</a:t>
+            </a:r>
+          </a:p>
+          <a:p>
+            <a:r>
+              <a:rPr sz="2000">
+                <a:solidFill>
+                  <a:srgbClr val="222833"/>
+                </a:solidFill>
+                <a:latin typeface="Cambria"/>
+              </a:rPr>
+              <a:t>7.  Challenges Faced &amp; Future Work</a:t>
+            </a:r>
+          </a:p>
+          <a:p>
+            <a:r>
+              <a:rPr sz="2000">
+                <a:solidFill>
+                  <a:srgbClr val="222833"/>
+                </a:solidFill>
+                <a:latin typeface="Cambria"/>
+              </a:rPr>
+              <a:t>8.  References</a:t>
+            </a:r>
+          </a:p>
+          <a:p>
+            <a:r>
+              <a:rPr sz="2000">
+                <a:solidFill>
+                  <a:srgbClr val="222833"/>
+                </a:solidFill>
+                <a:latin typeface="Cambria"/>
+              </a:rPr>
+              <a:t>9.  Team Contributions</a:t>
+            </a:r>
+          </a:p>
+        </p:txBody>
+      </p:sp>
+    </p:spTree>
+    <p:extLst>
+      <p:ext uri="{BB962C8B-B14F-4D97-AF65-F5344CB8AC3E}">
+        <p14:creationId xmlns:p14="http://schemas.microsoft.com/office/powerpoint/2010/main" val="866290265"/>
+      </p:ext>
+    </p:extLst>
+  </p:cSld>
+  <p:clrMapOvr>
+    <a:masterClrMapping/>
+  </p:clrMapOvr>
+</p:sld>
+</file>
+
+<file path=ppt/slides/slide20.xml><?xml version="1.0" encoding="utf-8"?>
 <p:sld xmlns:a="http://schemas.openxmlformats.org/drawingml/2006/main" xmlns:r="http://schemas.openxmlformats.org/officeDocument/2006/relationships" xmlns:p="http://schemas.openxmlformats.org/presentationml/2006/main">
   <p:cSld>
     <p:spTree>
@@ -9601,7 +9548,7 @@
 </p:sld>
 </file>
 
-<file path=ppt/slides/slide26.xml><?xml version="1.0" encoding="utf-8"?>
+<file path=ppt/slides/slide22.xml><?xml version="1.0" encoding="utf-8"?>
 <p:sld xmlns:a="http://schemas.openxmlformats.org/drawingml/2006/main" xmlns:r="http://schemas.openxmlformats.org/officeDocument/2006/relationships" xmlns:p="http://schemas.openxmlformats.org/presentationml/2006/main">
   <p:cSld>
     <p:spTree>
@@ -9640,7 +9587,7 @@
                 </a:solidFill>
                 <a:latin typeface="Cambria"/>
               </a:rPr>
-              <a:t>Progress Since the Last Review</a:t>
+              <a:t>Challenges Faced &amp; Future Work</a:t>
             </a:r>
           </a:p>
         </p:txBody>
@@ -9668,17 +9615,17 @@
             <a:r>
               <a:rPr sz="1800" b="1">
                 <a:solidFill>
-                  <a:srgbClr val="002060"/>
-                </a:solidFill>
-                <a:latin typeface="Cambria"/>
-              </a:rPr>
-              <a:t>Specification</a:t>
+                  <a:srgbClr val="B26A00"/>
+                </a:solidFill>
+                <a:latin typeface="Cambria"/>
+              </a:rPr>
+              <a:t>Challenges faced</a:t>
             </a:r>
           </a:p>
           <a:p>
             <a:pPr lvl="1">
               <a:spcAft>
-                <a:spcPts val="500"/>
+                <a:spcPts val="400"/>
               </a:spcAft>
             </a:pPr>
             <a:r>
@@ -9688,13 +9635,13 @@
                 </a:solidFill>
                 <a:latin typeface="Cambria"/>
               </a:rPr>
-              <a:t>Front matter numbered in roman (i-ix); body restarts at 1</a:t>
+              <a:t>Coordinating four data stores on one machine</a:t>
             </a:r>
           </a:p>
           <a:p>
             <a:pPr lvl="1">
               <a:spcAft>
-                <a:spcPts val="500"/>
+                <a:spcPts val="400"/>
               </a:spcAft>
             </a:pPr>
             <a:r>
@@ -9704,13 +9651,13 @@
                 </a:solidFill>
                 <a:latin typeface="Cambria"/>
               </a:rPr>
-              <a:t>Every reference cited in the text at its point of use, IEEE style</a:t>
+              <a:t>Keeping model output consistent — solved with a 30-point cap</a:t>
             </a:r>
           </a:p>
           <a:p>
             <a:pPr lvl="1">
               <a:spcAft>
-                <a:spcPts val="500"/>
+                <a:spcPts val="400"/>
               </a:spcAft>
             </a:pPr>
             <a:r>
@@ -9720,13 +9667,13 @@
                 </a:solidFill>
                 <a:latin typeface="Cambria"/>
               </a:rPr>
-              <a:t>Tables restyled — caption above, columns sized to content, none split across a page break</a:t>
+              <a:t>Writing Cypher queries for circular money-mule flows</a:t>
             </a:r>
           </a:p>
           <a:p>
             <a:pPr lvl="1">
               <a:spcAft>
-                <a:spcPts val="500"/>
+                <a:spcPts val="400"/>
               </a:spcAft>
             </a:pPr>
             <a:r>
@@ -9736,13 +9683,13 @@
                 </a:solidFill>
                 <a:latin typeface="Cambria"/>
               </a:rPr>
-              <a:t>32 functional requirements consolidated to 28 real, distinct ones</a:t>
+              <a:t>Two defects the benchmark exposed: a repeated request returned</a:t>
             </a:r>
           </a:p>
           <a:p>
             <a:pPr lvl="1">
               <a:spcAft>
-                <a:spcPts val="500"/>
+                <a:spcPts val="400"/>
               </a:spcAft>
             </a:pPr>
             <a:r>
@@ -9752,7 +9699,23 @@
                 </a:solidFill>
                 <a:latin typeface="Cambria"/>
               </a:rPr>
-              <a:t>Diagram set re-checked against the guide's notation comments and against the running code</a:t>
+              <a:t>a server error, and a parsing fault silently zeroed the AI</a:t>
+            </a:r>
+          </a:p>
+          <a:p>
+            <a:pPr lvl="1">
+              <a:spcAft>
+                <a:spcPts val="400"/>
+              </a:spcAft>
+            </a:pPr>
+            <a:r>
+              <a:rPr sz="1600" b="0">
+                <a:solidFill>
+                  <a:srgbClr val="222833"/>
+                </a:solidFill>
+                <a:latin typeface="Cambria"/>
+              </a:rPr>
+              <a:t>score — both fixed and covered by tests</a:t>
             </a:r>
           </a:p>
         </p:txBody>
@@ -9780,17 +9743,17 @@
             <a:r>
               <a:rPr sz="1800" b="1">
                 <a:solidFill>
-                  <a:srgbClr val="028090"/>
-                </a:solidFill>
-                <a:latin typeface="Cambria"/>
-              </a:rPr>
-              <a:t>Product</a:t>
+                  <a:srgbClr val="2E7D32"/>
+                </a:solidFill>
+                <a:latin typeface="Cambria"/>
+              </a:rPr>
+              <a:t>Future work</a:t>
             </a:r>
           </a:p>
           <a:p>
             <a:pPr lvl="1">
               <a:spcAft>
-                <a:spcPts val="500"/>
+                <a:spcPts val="400"/>
               </a:spcAft>
             </a:pPr>
             <a:r>
@@ -9800,13 +9763,13 @@
                 </a:solidFill>
                 <a:latin typeface="Cambria"/>
               </a:rPr>
-              <a:t>Flagged-transactions table made interactive — filters, search, sortable columns</a:t>
+              <a:t>Resolve the block-threshold trade-off from recorded scores</a:t>
             </a:r>
           </a:p>
           <a:p>
             <a:pPr lvl="1">
               <a:spcAft>
-                <a:spcPts val="500"/>
+                <a:spcPts val="400"/>
               </a:spcAft>
             </a:pPr>
             <a:r>
@@ -9816,13 +9779,13 @@
                 </a:solidFill>
                 <a:latin typeface="Cambria"/>
               </a:rPr>
-              <a:t>Entrance and count-up motion, with an automatic reduced-motion fallback</a:t>
+              <a:t>Add API authentication and request logging</a:t>
             </a:r>
           </a:p>
           <a:p>
             <a:pPr lvl="1">
               <a:spcAft>
-                <a:spcPts val="500"/>
+                <a:spcPts val="400"/>
               </a:spcAft>
             </a:pPr>
             <a:r>
@@ -9832,13 +9795,13 @@
                 </a:solidFill>
                 <a:latin typeface="Cambria"/>
               </a:rPr>
-              <a:t>Static demo mode: the dashboard runs from a snapshot with no live backend</a:t>
+              <a:t>Fraud-ring visualisation on the graph endpoint</a:t>
             </a:r>
           </a:p>
           <a:p>
             <a:pPr lvl="1">
               <a:spcAft>
-                <a:spcPts val="500"/>
+                <a:spcPts val="400"/>
               </a:spcAft>
             </a:pPr>
             <a:r>
@@ -9848,7 +9811,73 @@
                 </a:solidFill>
                 <a:latin typeface="Cambria"/>
               </a:rPr>
-              <a:t>Weekly-report generator with an automatic duplicate-reference check across weeks</a:t>
+              <a:t>Investigate the 7 undetected frauds; fan-in / fan-out patterns</a:t>
+            </a:r>
+          </a:p>
+          <a:p>
+            <a:pPr lvl="1">
+              <a:spcAft>
+                <a:spcPts val="400"/>
+              </a:spcAft>
+            </a:pPr>
+            <a:r>
+              <a:rPr sz="1600" b="0">
+                <a:solidFill>
+                  <a:srgbClr val="222833"/>
+                </a:solidFill>
+                <a:latin typeface="Cambria"/>
+              </a:rPr>
+              <a:t>Train a supervised classifier as a fourth signal</a:t>
+            </a:r>
+          </a:p>
+          <a:p>
+            <a:pPr lvl="1">
+              <a:spcAft>
+                <a:spcPts val="400"/>
+              </a:spcAft>
+            </a:pPr>
+            <a:r>
+              <a:rPr sz="1600" b="0">
+                <a:solidFill>
+                  <a:srgbClr val="222833"/>
+                </a:solidFill>
+                <a:latin typeface="Cambria"/>
+              </a:rPr>
+              <a:t>Reduce latency, presently dominated by the local model</a:t>
+            </a:r>
+          </a:p>
+        </p:txBody>
+      </p:sp>
+      <p:sp>
+        <p:nvSpPr>
+          <p:cNvPr id="5" name="TextBox 4"/>
+          <p:cNvSpPr txBox="1"/>
+          <p:nvPr/>
+        </p:nvSpPr>
+        <p:spPr>
+          <a:xfrm>
+            <a:off x="18288" y="109728"/>
+            <a:ext cx="8229600" cy="292608"/>
+          </a:xfrm>
+          <a:prstGeom prst="rect">
+            <a:avLst/>
+          </a:prstGeom>
+          <a:noFill/>
+        </p:spPr>
+        <p:txBody>
+          <a:bodyPr wrap="none">
+            <a:spAutoFit/>
+          </a:bodyPr>
+          <a:lstStyle/>
+          <a:p>
+            <a:r>
+              <a:rPr sz="1100" b="1">
+                <a:solidFill>
+                  <a:srgbClr val="028090"/>
+                </a:solidFill>
+                <a:latin typeface="Cambria"/>
+              </a:rPr>
+              <a:t>07 · CHALLENGES &amp; FUTURE WORK</a:t>
             </a:r>
           </a:p>
         </p:txBody>
@@ -9861,7 +9890,7 @@
 </p:sld>
 </file>
 
-<file path=ppt/slides/slide27.xml><?xml version="1.0" encoding="utf-8"?>
+<file path=ppt/slides/slide24.xml><?xml version="1.0" encoding="utf-8"?>
 <p:sld xmlns:a="http://schemas.openxmlformats.org/drawingml/2006/main" xmlns:r="http://schemas.openxmlformats.org/officeDocument/2006/relationships" xmlns:p="http://schemas.openxmlformats.org/presentationml/2006/main">
   <p:cSld>
     <p:spTree>
@@ -9900,7 +9929,7 @@
                 </a:solidFill>
                 <a:latin typeface="Cambria"/>
               </a:rPr>
-              <a:t>Challenges Faced &amp; Future Work</a:t>
+              <a:t>References</a:t>
             </a:r>
           </a:p>
         </p:txBody>
@@ -9912,7 +9941,7 @@
             <a:spLocks noGrp="1"/>
           </p:cNvSpPr>
           <p:nvPr>
-            <p:ph sz="half" idx="1"/>
+            <p:ph idx="1"/>
           </p:nvPr>
         </p:nvSpPr>
         <p:spPr/>
@@ -9926,127 +9955,15 @@
               </a:spcAft>
             </a:pPr>
             <a:r>
-              <a:rPr sz="1800" b="1">
-                <a:solidFill>
-                  <a:srgbClr val="B26A00"/>
-                </a:solidFill>
-                <a:latin typeface="Cambria"/>
-              </a:rPr>
-              <a:t>Challenges faced</a:t>
-            </a:r>
-          </a:p>
-          <a:p>
-            <a:pPr lvl="1">
-              <a:spcAft>
-                <a:spcPts val="400"/>
-              </a:spcAft>
-            </a:pPr>
-            <a:r>
-              <a:rPr sz="1600" b="0">
-                <a:solidFill>
-                  <a:srgbClr val="222833"/>
-                </a:solidFill>
-                <a:latin typeface="Cambria"/>
-              </a:rPr>
-              <a:t>Coordinating four data stores on one machine</a:t>
-            </a:r>
-          </a:p>
-          <a:p>
-            <a:pPr lvl="1">
-              <a:spcAft>
-                <a:spcPts val="400"/>
-              </a:spcAft>
-            </a:pPr>
-            <a:r>
-              <a:rPr sz="1600" b="0">
-                <a:solidFill>
-                  <a:srgbClr val="222833"/>
-                </a:solidFill>
-                <a:latin typeface="Cambria"/>
-              </a:rPr>
-              <a:t>Keeping model output consistent — solved with a 30-point cap</a:t>
-            </a:r>
-          </a:p>
-          <a:p>
-            <a:pPr lvl="1">
-              <a:spcAft>
-                <a:spcPts val="400"/>
-              </a:spcAft>
-            </a:pPr>
-            <a:r>
-              <a:rPr sz="1600" b="0">
-                <a:solidFill>
-                  <a:srgbClr val="222833"/>
-                </a:solidFill>
-                <a:latin typeface="Cambria"/>
-              </a:rPr>
-              <a:t>Writing Cypher queries for circular money-mule flows</a:t>
-            </a:r>
-          </a:p>
-          <a:p>
-            <a:pPr lvl="1">
-              <a:spcAft>
-                <a:spcPts val="400"/>
-              </a:spcAft>
-            </a:pPr>
-            <a:r>
-              <a:rPr sz="1600" b="0">
-                <a:solidFill>
-                  <a:srgbClr val="222833"/>
-                </a:solidFill>
-                <a:latin typeface="Cambria"/>
-              </a:rPr>
-              <a:t>Two defects the benchmark exposed: a repeated request returned</a:t>
-            </a:r>
-          </a:p>
-          <a:p>
-            <a:pPr lvl="1">
-              <a:spcAft>
-                <a:spcPts val="400"/>
-              </a:spcAft>
-            </a:pPr>
-            <a:r>
-              <a:rPr sz="1600" b="0">
-                <a:solidFill>
-                  <a:srgbClr val="222833"/>
-                </a:solidFill>
-                <a:latin typeface="Cambria"/>
-              </a:rPr>
-              <a:t>a server error, and a parsing fault silently zeroed the AI</a:t>
-            </a:r>
-          </a:p>
-          <a:p>
-            <a:pPr lvl="1">
-              <a:spcAft>
-                <a:spcPts val="400"/>
-              </a:spcAft>
-            </a:pPr>
-            <a:r>
-              <a:rPr sz="1600" b="0">
-                <a:solidFill>
-                  <a:srgbClr val="222833"/>
-                </a:solidFill>
-                <a:latin typeface="Cambria"/>
-              </a:rPr>
-              <a:t>score — both fixed and covered by tests</a:t>
-            </a:r>
-          </a:p>
-        </p:txBody>
-      </p:sp>
-      <p:sp>
-        <p:nvSpPr>
-          <p:cNvPr id="4" name="Content Placeholder 3"/>
-          <p:cNvSpPr>
-            <a:spLocks noGrp="1"/>
-          </p:cNvSpPr>
-          <p:nvPr>
-            <p:ph sz="half" idx="2"/>
-          </p:nvPr>
-        </p:nvSpPr>
-        <p:spPr/>
-        <p:txBody>
-          <a:bodyPr wrap="square"/>
-          <a:lstStyle/>
+              <a:rPr sz="1300" b="0">
+                <a:solidFill>
+                  <a:srgbClr val="222833"/>
+                </a:solidFill>
+                <a:latin typeface="Cambria"/>
+              </a:rPr>
+              <a:t>[1]  Van Vlasselaer, V. et al. (2015). APATE: A novel approach for automated credit card transaction fraud detection using network-based extensions. Decision Support Systems, 75, 38–48.</a:t>
+            </a:r>
+          </a:p>
           <a:p>
             <a:pPr>
               <a:spcAft>
@@ -10054,143 +9971,77 @@
               </a:spcAft>
             </a:pPr>
             <a:r>
-              <a:rPr sz="1800" b="1">
-                <a:solidFill>
-                  <a:srgbClr val="2E7D32"/>
-                </a:solidFill>
-                <a:latin typeface="Cambria"/>
-              </a:rPr>
-              <a:t>Future work</a:t>
-            </a:r>
-          </a:p>
-          <a:p>
-            <a:pPr lvl="1">
+              <a:rPr sz="1300" b="0">
+                <a:solidFill>
+                  <a:srgbClr val="222833"/>
+                </a:solidFill>
+                <a:latin typeface="Cambria"/>
+              </a:rPr>
+              <a:t>[2]  FICO. Falcon Fraud Manager — product documentation. fico.com.</a:t>
+            </a:r>
+          </a:p>
+          <a:p>
+            <a:pPr>
               <a:spcAft>
-                <a:spcPts val="400"/>
+                <a:spcPts val="700"/>
               </a:spcAft>
             </a:pPr>
             <a:r>
-              <a:rPr sz="1600" b="0">
-                <a:solidFill>
-                  <a:srgbClr val="222833"/>
-                </a:solidFill>
-                <a:latin typeface="Cambria"/>
-              </a:rPr>
-              <a:t>Resolve the block-threshold trade-off from recorded scores</a:t>
-            </a:r>
-          </a:p>
-          <a:p>
-            <a:pPr lvl="1">
+              <a:rPr sz="1300" b="0">
+                <a:solidFill>
+                  <a:srgbClr val="222833"/>
+                </a:solidFill>
+                <a:latin typeface="Cambria"/>
+              </a:rPr>
+              <a:t>[3]  Feedzai. RiskOps platform overview. feedzai.com.</a:t>
+            </a:r>
+          </a:p>
+          <a:p>
+            <a:pPr>
               <a:spcAft>
-                <a:spcPts val="400"/>
+                <a:spcPts val="700"/>
               </a:spcAft>
             </a:pPr>
             <a:r>
-              <a:rPr sz="1600" b="0">
-                <a:solidFill>
-                  <a:srgbClr val="222833"/>
-                </a:solidFill>
-                <a:latin typeface="Cambria"/>
-              </a:rPr>
-              <a:t>Add API authentication and request logging</a:t>
-            </a:r>
-          </a:p>
-          <a:p>
-            <a:pPr lvl="1">
+              <a:rPr sz="1300" b="0">
+                <a:solidFill>
+                  <a:srgbClr val="222833"/>
+                </a:solidFill>
+                <a:latin typeface="Cambria"/>
+              </a:rPr>
+              <a:t>[4]  Featurespace. ARIC Risk Hub — adaptive behavioural analytics. featurespace.com.</a:t>
+            </a:r>
+          </a:p>
+          <a:p>
+            <a:pPr>
               <a:spcAft>
-                <a:spcPts val="400"/>
+                <a:spcPts val="700"/>
               </a:spcAft>
             </a:pPr>
             <a:r>
-              <a:rPr sz="1600" b="0">
-                <a:solidFill>
-                  <a:srgbClr val="222833"/>
-                </a:solidFill>
-                <a:latin typeface="Cambria"/>
-              </a:rPr>
-              <a:t>Fraud-ring visualisation on the graph endpoint</a:t>
-            </a:r>
-          </a:p>
-          <a:p>
-            <a:pPr lvl="1">
+              <a:rPr sz="1300" b="0">
+                <a:solidFill>
+                  <a:srgbClr val="222833"/>
+                </a:solidFill>
+                <a:latin typeface="Cambria"/>
+              </a:rPr>
+              <a:t>[5]  Neo4j. Graph algorithms for fraud detection — developer guide. neo4j.com.</a:t>
+            </a:r>
+          </a:p>
+          <a:p>
+            <a:pPr>
               <a:spcAft>
-                <a:spcPts val="400"/>
+                <a:spcPts val="700"/>
               </a:spcAft>
             </a:pPr>
             <a:r>
-              <a:rPr sz="1600" b="0">
-                <a:solidFill>
-                  <a:srgbClr val="222833"/>
-                </a:solidFill>
-                <a:latin typeface="Cambria"/>
-              </a:rPr>
-              <a:t>Investigate the 7 undetected frauds; fan-in / fan-out patterns</a:t>
-            </a:r>
-          </a:p>
-          <a:p>
-            <a:pPr lvl="1">
-              <a:spcAft>
-                <a:spcPts val="400"/>
-              </a:spcAft>
-            </a:pPr>
-            <a:r>
-              <a:rPr sz="1600" b="0">
-                <a:solidFill>
-                  <a:srgbClr val="222833"/>
-                </a:solidFill>
-                <a:latin typeface="Cambria"/>
-              </a:rPr>
-              <a:t>Train a supervised classifier as a fourth signal</a:t>
-            </a:r>
-          </a:p>
-          <a:p>
-            <a:pPr lvl="1">
-              <a:spcAft>
-                <a:spcPts val="400"/>
-              </a:spcAft>
-            </a:pPr>
-            <a:r>
-              <a:rPr sz="1600" b="0">
-                <a:solidFill>
-                  <a:srgbClr val="222833"/>
-                </a:solidFill>
-                <a:latin typeface="Cambria"/>
-              </a:rPr>
-              <a:t>Reduce latency, presently dominated by the local model</a:t>
-            </a:r>
-          </a:p>
-        </p:txBody>
-      </p:sp>
-      <p:sp>
-        <p:nvSpPr>
-          <p:cNvPr id="5" name="TextBox 4"/>
-          <p:cNvSpPr txBox="1"/>
-          <p:nvPr/>
-        </p:nvSpPr>
-        <p:spPr>
-          <a:xfrm>
-            <a:off x="18288" y="109728"/>
-            <a:ext cx="8229600" cy="292608"/>
-          </a:xfrm>
-          <a:prstGeom prst="rect">
-            <a:avLst/>
-          </a:prstGeom>
-          <a:noFill/>
-        </p:spPr>
-        <p:txBody>
-          <a:bodyPr wrap="none">
-            <a:spAutoFit/>
-          </a:bodyPr>
-          <a:lstStyle/>
-          <a:p>
-            <a:r>
-              <a:rPr sz="1100" b="1">
-                <a:solidFill>
-                  <a:srgbClr val="028090"/>
-                </a:solidFill>
-                <a:latin typeface="Cambria"/>
-              </a:rPr>
-              <a:t>07 · CHALLENGES &amp; FUTURE WORK</a:t>
+              <a:rPr sz="1300" b="0">
+                <a:solidFill>
+                  <a:srgbClr val="222833"/>
+                </a:solidFill>
+                <a:latin typeface="Cambria"/>
+              </a:rPr>
+              <a:t>[6]  LangChain &amp; ChromaDB documentation — retrieval-augmented generation.</a:t>
             </a:r>
           </a:p>
         </p:txBody>
@@ -10203,873 +10054,7 @@
 </p:sld>
 </file>
 
-<file path=ppt/slides/slide28.xml><?xml version="1.0" encoding="utf-8"?>
-<p:sld xmlns:a="http://schemas.openxmlformats.org/drawingml/2006/main" xmlns:r="http://schemas.openxmlformats.org/officeDocument/2006/relationships" xmlns:p="http://schemas.openxmlformats.org/presentationml/2006/main">
-  <p:cSld>
-    <p:spTree>
-      <p:nvGrpSpPr>
-        <p:cNvPr id="1" name=""/>
-        <p:cNvGrpSpPr/>
-        <p:nvPr/>
-      </p:nvGrpSpPr>
-      <p:grpSpPr>
-        <a:xfrm>
-          <a:off x="0" y="0"/>
-          <a:ext cx="0" cy="0"/>
-          <a:chOff x="0" y="0"/>
-          <a:chExt cx="0" cy="0"/>
-        </a:xfrm>
-      </p:grpSpPr>
-      <p:sp>
-        <p:nvSpPr>
-          <p:cNvPr id="2" name="Title 1"/>
-          <p:cNvSpPr>
-            <a:spLocks noGrp="1"/>
-          </p:cNvSpPr>
-          <p:nvPr>
-            <p:ph type="title"/>
-          </p:nvPr>
-        </p:nvSpPr>
-        <p:spPr/>
-        <p:txBody>
-          <a:bodyPr/>
-          <a:lstStyle/>
-          <a:p>
-            <a:r>
-              <a:rPr sz="2800" b="1">
-                <a:solidFill>
-                  <a:srgbClr val="002060"/>
-                </a:solidFill>
-                <a:latin typeface="Cambria"/>
-              </a:rPr>
-              <a:t>Conclusion — Where the Project Stands</a:t>
-            </a:r>
-          </a:p>
-        </p:txBody>
-      </p:sp>
-      <p:sp>
-        <p:nvSpPr>
-          <p:cNvPr id="3" name="Rounded Rectangle 2"/>
-          <p:cNvSpPr/>
-          <p:nvPr/>
-        </p:nvSpPr>
-        <p:spPr>
-          <a:xfrm>
-            <a:off x="457200" y="1828800"/>
-            <a:ext cx="2743200" cy="2834640"/>
-          </a:xfrm>
-          <a:prstGeom prst="roundRect">
-            <a:avLst/>
-          </a:prstGeom>
-          <a:solidFill>
-            <a:srgbClr val="F4F6FA"/>
-          </a:solidFill>
-          <a:ln>
-            <a:solidFill>
-              <a:srgbClr val="C7D0DE"/>
-            </a:solidFill>
-          </a:ln>
-          <a:effectLst/>
-        </p:spPr>
-        <p:style>
-          <a:lnRef idx="1">
-            <a:schemeClr val="accent1"/>
-          </a:lnRef>
-          <a:fillRef idx="3">
-            <a:schemeClr val="accent1"/>
-          </a:fillRef>
-          <a:effectRef idx="2">
-            <a:schemeClr val="accent1"/>
-          </a:effectRef>
-          <a:fontRef idx="minor">
-            <a:schemeClr val="lt1"/>
-          </a:fontRef>
-        </p:style>
-        <p:txBody>
-          <a:bodyPr wrap="square" lIns="146304" tIns="182880" rIns="128016" rtlCol="0" anchor="ctr"/>
-          <a:lstStyle/>
-          <a:p>
-            <a:pPr algn="ctr">
-              <a:spcAft>
-                <a:spcPts val="800"/>
-              </a:spcAft>
-            </a:pPr>
-            <a:r>
-              <a:rPr sz="1400" b="1">
-                <a:solidFill>
-                  <a:srgbClr val="002060"/>
-                </a:solidFill>
-                <a:latin typeface="Cambria"/>
-              </a:rPr>
-              <a:t>Measured, not asserted</a:t>
-            </a:r>
-          </a:p>
-          <a:p>
-            <a:pPr>
-              <a:spcAft>
-                <a:spcPts val="800"/>
-              </a:spcAft>
-            </a:pPr>
-            <a:r>
-              <a:rPr sz="1200" b="0">
-                <a:solidFill>
-                  <a:srgbClr val="222833"/>
-                </a:solidFill>
-                <a:latin typeface="Cambria"/>
-              </a:rPr>
-              <a:t>96.3% precision, 100% recall, F1 0.98 on 208 labelled transactions.</a:t>
-            </a:r>
-          </a:p>
-        </p:txBody>
-      </p:sp>
-      <p:sp>
-        <p:nvSpPr>
-          <p:cNvPr id="4" name="Rounded Rectangle 3"/>
-          <p:cNvSpPr/>
-          <p:nvPr/>
-        </p:nvSpPr>
-        <p:spPr>
-          <a:xfrm>
-            <a:off x="3447288" y="1828800"/>
-            <a:ext cx="2743200" cy="2834640"/>
-          </a:xfrm>
-          <a:prstGeom prst="roundRect">
-            <a:avLst/>
-          </a:prstGeom>
-          <a:solidFill>
-            <a:srgbClr val="F4F6FA"/>
-          </a:solidFill>
-          <a:ln>
-            <a:solidFill>
-              <a:srgbClr val="C7D0DE"/>
-            </a:solidFill>
-          </a:ln>
-          <a:effectLst/>
-        </p:spPr>
-        <p:style>
-          <a:lnRef idx="1">
-            <a:schemeClr val="accent1"/>
-          </a:lnRef>
-          <a:fillRef idx="3">
-            <a:schemeClr val="accent1"/>
-          </a:fillRef>
-          <a:effectRef idx="2">
-            <a:schemeClr val="accent1"/>
-          </a:effectRef>
-          <a:fontRef idx="minor">
-            <a:schemeClr val="lt1"/>
-          </a:fontRef>
-        </p:style>
-        <p:txBody>
-          <a:bodyPr wrap="square" lIns="146304" tIns="182880" rIns="128016" rtlCol="0" anchor="ctr"/>
-          <a:lstStyle/>
-          <a:p>
-            <a:pPr algn="ctr">
-              <a:spcAft>
-                <a:spcPts val="800"/>
-              </a:spcAft>
-            </a:pPr>
-            <a:r>
-              <a:rPr sz="1400" b="1">
-                <a:solidFill>
-                  <a:srgbClr val="028090"/>
-                </a:solidFill>
-                <a:latin typeface="Cambria"/>
-              </a:rPr>
-              <a:t>The graph layer earns its place</a:t>
-            </a:r>
-          </a:p>
-          <a:p>
-            <a:pPr>
-              <a:spcAft>
-                <a:spcPts val="800"/>
-              </a:spcAft>
-            </a:pPr>
-            <a:r>
-              <a:rPr sz="1200" b="0">
-                <a:solidFill>
-                  <a:srgbClr val="222833"/>
-                </a:solidFill>
-                <a:latin typeface="Cambria"/>
-              </a:rPr>
-              <a:t>All 36 planted mule-ring transactions were detected.</a:t>
-            </a:r>
-          </a:p>
-        </p:txBody>
-      </p:sp>
-      <p:sp>
-        <p:nvSpPr>
-          <p:cNvPr id="5" name="Rounded Rectangle 4"/>
-          <p:cNvSpPr/>
-          <p:nvPr/>
-        </p:nvSpPr>
-        <p:spPr>
-          <a:xfrm>
-            <a:off x="6437376" y="1828800"/>
-            <a:ext cx="2743200" cy="2834640"/>
-          </a:xfrm>
-          <a:prstGeom prst="roundRect">
-            <a:avLst/>
-          </a:prstGeom>
-          <a:solidFill>
-            <a:srgbClr val="F4F6FA"/>
-          </a:solidFill>
-          <a:ln>
-            <a:solidFill>
-              <a:srgbClr val="C7D0DE"/>
-            </a:solidFill>
-          </a:ln>
-          <a:effectLst/>
-        </p:spPr>
-        <p:style>
-          <a:lnRef idx="1">
-            <a:schemeClr val="accent1"/>
-          </a:lnRef>
-          <a:fillRef idx="3">
-            <a:schemeClr val="accent1"/>
-          </a:fillRef>
-          <a:effectRef idx="2">
-            <a:schemeClr val="accent1"/>
-          </a:effectRef>
-          <a:fontRef idx="minor">
-            <a:schemeClr val="lt1"/>
-          </a:fontRef>
-        </p:style>
-        <p:txBody>
-          <a:bodyPr wrap="square" lIns="146304" tIns="182880" rIns="128016" rtlCol="0" anchor="ctr"/>
-          <a:lstStyle/>
-          <a:p>
-            <a:pPr algn="ctr">
-              <a:spcAft>
-                <a:spcPts val="800"/>
-              </a:spcAft>
-            </a:pPr>
-            <a:r>
-              <a:rPr sz="1400" b="1">
-                <a:solidFill>
-                  <a:srgbClr val="C62828"/>
-                </a:solidFill>
-                <a:latin typeface="Cambria"/>
-              </a:rPr>
-              <a:t>A finding worth reporting</a:t>
-            </a:r>
-          </a:p>
-          <a:p>
-            <a:pPr>
-              <a:spcAft>
-                <a:spcPts val="800"/>
-              </a:spcAft>
-            </a:pPr>
-            <a:r>
-              <a:rPr sz="1200" b="0">
-                <a:solidFill>
-                  <a:srgbClr val="222833"/>
-                </a:solidFill>
-                <a:latin typeface="Cambria"/>
-              </a:rPr>
-              <a:t>Nothing reaches the block threshold; every catch reaches an analyst.</a:t>
-            </a:r>
-          </a:p>
-        </p:txBody>
-      </p:sp>
-      <p:sp>
-        <p:nvSpPr>
-          <p:cNvPr id="6" name="Rounded Rectangle 5"/>
-          <p:cNvSpPr/>
-          <p:nvPr/>
-        </p:nvSpPr>
-        <p:spPr>
-          <a:xfrm>
-            <a:off x="9427464" y="1828800"/>
-            <a:ext cx="2743200" cy="2834640"/>
-          </a:xfrm>
-          <a:prstGeom prst="roundRect">
-            <a:avLst/>
-          </a:prstGeom>
-          <a:solidFill>
-            <a:srgbClr val="F4F6FA"/>
-          </a:solidFill>
-          <a:ln>
-            <a:solidFill>
-              <a:srgbClr val="C7D0DE"/>
-            </a:solidFill>
-          </a:ln>
-          <a:effectLst/>
-        </p:spPr>
-        <p:style>
-          <a:lnRef idx="1">
-            <a:schemeClr val="accent1"/>
-          </a:lnRef>
-          <a:fillRef idx="3">
-            <a:schemeClr val="accent1"/>
-          </a:fillRef>
-          <a:effectRef idx="2">
-            <a:schemeClr val="accent1"/>
-          </a:effectRef>
-          <a:fontRef idx="minor">
-            <a:schemeClr val="lt1"/>
-          </a:fontRef>
-        </p:style>
-        <p:txBody>
-          <a:bodyPr wrap="square" lIns="146304" tIns="182880" rIns="128016" rtlCol="0" anchor="ctr"/>
-          <a:lstStyle/>
-          <a:p>
-            <a:pPr algn="ctr">
-              <a:spcAft>
-                <a:spcPts val="800"/>
-              </a:spcAft>
-            </a:pPr>
-            <a:r>
-              <a:rPr sz="1400" b="1">
-                <a:solidFill>
-                  <a:srgbClr val="2E7D32"/>
-                </a:solidFill>
-                <a:latin typeface="Cambria"/>
-              </a:rPr>
-              <a:t>Engineering discipline</a:t>
-            </a:r>
-          </a:p>
-          <a:p>
-            <a:pPr>
-              <a:spcAft>
-                <a:spcPts val="800"/>
-              </a:spcAft>
-            </a:pPr>
-            <a:r>
-              <a:rPr sz="1200" b="0">
-                <a:solidFill>
-                  <a:srgbClr val="222833"/>
-                </a:solidFill>
-                <a:latin typeface="Cambria"/>
-              </a:rPr>
-              <a:t>113 automated tests, continuous integration, one-command deployment.</a:t>
-            </a:r>
-          </a:p>
-        </p:txBody>
-      </p:sp>
-    </p:spTree>
-  </p:cSld>
-  <p:clrMapOvr>
-    <a:masterClrMapping/>
-  </p:clrMapOvr>
-</p:sld>
-</file>
-
-<file path=ppt/slides/slide29.xml><?xml version="1.0" encoding="utf-8"?>
-<p:sld xmlns:a="http://schemas.openxmlformats.org/drawingml/2006/main" xmlns:r="http://schemas.openxmlformats.org/officeDocument/2006/relationships" xmlns:p="http://schemas.openxmlformats.org/presentationml/2006/main">
-  <p:cSld>
-    <p:spTree>
-      <p:nvGrpSpPr>
-        <p:cNvPr id="1" name=""/>
-        <p:cNvGrpSpPr/>
-        <p:nvPr/>
-      </p:nvGrpSpPr>
-      <p:grpSpPr>
-        <a:xfrm>
-          <a:off x="0" y="0"/>
-          <a:ext cx="0" cy="0"/>
-          <a:chOff x="0" y="0"/>
-          <a:chExt cx="0" cy="0"/>
-        </a:xfrm>
-      </p:grpSpPr>
-      <p:sp>
-        <p:nvSpPr>
-          <p:cNvPr id="2" name="Title 1"/>
-          <p:cNvSpPr>
-            <a:spLocks noGrp="1"/>
-          </p:cNvSpPr>
-          <p:nvPr>
-            <p:ph type="title"/>
-          </p:nvPr>
-        </p:nvSpPr>
-        <p:spPr/>
-        <p:txBody>
-          <a:bodyPr/>
-          <a:lstStyle/>
-          <a:p>
-            <a:r>
-              <a:rPr sz="2800" b="1">
-                <a:solidFill>
-                  <a:srgbClr val="002060"/>
-                </a:solidFill>
-                <a:latin typeface="Cambria"/>
-              </a:rPr>
-              <a:t>References</a:t>
-            </a:r>
-          </a:p>
-        </p:txBody>
-      </p:sp>
-      <p:sp>
-        <p:nvSpPr>
-          <p:cNvPr id="3" name="Content Placeholder 2"/>
-          <p:cNvSpPr>
-            <a:spLocks noGrp="1"/>
-          </p:cNvSpPr>
-          <p:nvPr>
-            <p:ph idx="1"/>
-          </p:nvPr>
-        </p:nvSpPr>
-        <p:spPr/>
-        <p:txBody>
-          <a:bodyPr wrap="square"/>
-          <a:lstStyle/>
-          <a:p>
-            <a:pPr>
-              <a:spcAft>
-                <a:spcPts val="700"/>
-              </a:spcAft>
-            </a:pPr>
-            <a:r>
-              <a:rPr sz="1300" b="0">
-                <a:solidFill>
-                  <a:srgbClr val="222833"/>
-                </a:solidFill>
-                <a:latin typeface="Cambria"/>
-              </a:rPr>
-              <a:t>[1]  Van Vlasselaer, V. et al. (2015). APATE: A novel approach for automated credit card transaction fraud detection using network-based extensions. Decision Support Systems, 75, 38–48.</a:t>
-            </a:r>
-          </a:p>
-          <a:p>
-            <a:pPr>
-              <a:spcAft>
-                <a:spcPts val="700"/>
-              </a:spcAft>
-            </a:pPr>
-            <a:r>
-              <a:rPr sz="1300" b="0">
-                <a:solidFill>
-                  <a:srgbClr val="222833"/>
-                </a:solidFill>
-                <a:latin typeface="Cambria"/>
-              </a:rPr>
-              <a:t>[2]  FICO. Falcon Fraud Manager — product documentation. fico.com.</a:t>
-            </a:r>
-          </a:p>
-          <a:p>
-            <a:pPr>
-              <a:spcAft>
-                <a:spcPts val="700"/>
-              </a:spcAft>
-            </a:pPr>
-            <a:r>
-              <a:rPr sz="1300" b="0">
-                <a:solidFill>
-                  <a:srgbClr val="222833"/>
-                </a:solidFill>
-                <a:latin typeface="Cambria"/>
-              </a:rPr>
-              <a:t>[3]  Feedzai. RiskOps platform overview. feedzai.com.</a:t>
-            </a:r>
-          </a:p>
-          <a:p>
-            <a:pPr>
-              <a:spcAft>
-                <a:spcPts val="700"/>
-              </a:spcAft>
-            </a:pPr>
-            <a:r>
-              <a:rPr sz="1300" b="0">
-                <a:solidFill>
-                  <a:srgbClr val="222833"/>
-                </a:solidFill>
-                <a:latin typeface="Cambria"/>
-              </a:rPr>
-              <a:t>[4]  Featurespace. ARIC Risk Hub — adaptive behavioural analytics. featurespace.com.</a:t>
-            </a:r>
-          </a:p>
-          <a:p>
-            <a:pPr>
-              <a:spcAft>
-                <a:spcPts val="700"/>
-              </a:spcAft>
-            </a:pPr>
-            <a:r>
-              <a:rPr sz="1300" b="0">
-                <a:solidFill>
-                  <a:srgbClr val="222833"/>
-                </a:solidFill>
-                <a:latin typeface="Cambria"/>
-              </a:rPr>
-              <a:t>[5]  Neo4j. Graph algorithms for fraud detection — developer guide. neo4j.com.</a:t>
-            </a:r>
-          </a:p>
-          <a:p>
-            <a:pPr>
-              <a:spcAft>
-                <a:spcPts val="700"/>
-              </a:spcAft>
-            </a:pPr>
-            <a:r>
-              <a:rPr sz="1300" b="0">
-                <a:solidFill>
-                  <a:srgbClr val="222833"/>
-                </a:solidFill>
-                <a:latin typeface="Cambria"/>
-              </a:rPr>
-              <a:t>[6]  LangChain &amp; ChromaDB documentation — retrieval-augmented generation.</a:t>
-            </a:r>
-          </a:p>
-        </p:txBody>
-      </p:sp>
-    </p:spTree>
-  </p:cSld>
-  <p:clrMapOvr>
-    <a:masterClrMapping/>
-  </p:clrMapOvr>
-</p:sld>
-</file>
-
-<file path=ppt/slides/slide3.xml><?xml version="1.0" encoding="utf-8"?>
-<p:sld xmlns:a="http://schemas.openxmlformats.org/drawingml/2006/main" xmlns:r="http://schemas.openxmlformats.org/officeDocument/2006/relationships" xmlns:p="http://schemas.openxmlformats.org/presentationml/2006/main">
-  <p:cSld>
-    <p:spTree>
-      <p:nvGrpSpPr>
-        <p:cNvPr id="1" name=""/>
-        <p:cNvGrpSpPr/>
-        <p:nvPr/>
-      </p:nvGrpSpPr>
-      <p:grpSpPr>
-        <a:xfrm>
-          <a:off x="0" y="0"/>
-          <a:ext cx="0" cy="0"/>
-          <a:chOff x="0" y="0"/>
-          <a:chExt cx="0" cy="0"/>
-        </a:xfrm>
-      </p:grpSpPr>
-      <p:sp>
-        <p:nvSpPr>
-          <p:cNvPr id="2" name="Title 1"/>
-          <p:cNvSpPr>
-            <a:spLocks noGrp="1"/>
-          </p:cNvSpPr>
-          <p:nvPr>
-            <p:ph type="title"/>
-          </p:nvPr>
-        </p:nvSpPr>
-        <p:spPr/>
-        <p:txBody>
-          <a:bodyPr/>
-          <a:lstStyle/>
-          <a:p>
-            <a:r>
-              <a:rPr sz="2800" b="1">
-                <a:solidFill>
-                  <a:srgbClr val="002060"/>
-                </a:solidFill>
-                <a:latin typeface="Cambria"/>
-              </a:rPr>
-              <a:t>Project Proposal Review — Comments &amp; Actions</a:t>
-            </a:r>
-          </a:p>
-        </p:txBody>
-      </p:sp>
-      <p:sp>
-        <p:nvSpPr>
-          <p:cNvPr id="3" name="Content Placeholder 2"/>
-          <p:cNvSpPr>
-            <a:spLocks noGrp="1"/>
-          </p:cNvSpPr>
-          <p:nvPr>
-            <p:ph sz="half" idx="1"/>
-          </p:nvPr>
-        </p:nvSpPr>
-        <p:spPr/>
-        <p:txBody>
-          <a:bodyPr wrap="square">
-            <a:normAutofit/>
-          </a:bodyPr>
-          <a:lstStyle/>
-          <a:p>
-            <a:pPr>
-              <a:spcAft>
-                <a:spcPts val="700"/>
-              </a:spcAft>
-            </a:pPr>
-            <a:r>
-              <a:rPr sz="1800" b="1" dirty="0">
-                <a:solidFill>
-                  <a:srgbClr val="002060"/>
-                </a:solidFill>
-                <a:latin typeface="Cambria"/>
-              </a:rPr>
-              <a:t>Comments received</a:t>
-            </a:r>
-          </a:p>
-          <a:p>
-            <a:pPr lvl="1">
-              <a:spcAft>
-                <a:spcPts val="400"/>
-              </a:spcAft>
-            </a:pPr>
-            <a:r>
-              <a:rPr sz="1600" b="0" dirty="0">
-                <a:solidFill>
-                  <a:srgbClr val="222833"/>
-                </a:solidFill>
-                <a:latin typeface="Cambria"/>
-              </a:rPr>
-              <a:t>Show measured evidence, not just a working demo</a:t>
-            </a:r>
-          </a:p>
-          <a:p>
-            <a:pPr lvl="1">
-              <a:spcAft>
-                <a:spcPts val="400"/>
-              </a:spcAft>
-            </a:pPr>
-            <a:r>
-              <a:rPr sz="1600" b="0" dirty="0">
-                <a:solidFill>
-                  <a:srgbClr val="222833"/>
-                </a:solidFill>
-                <a:latin typeface="Cambria"/>
-              </a:rPr>
-              <a:t>SRS: correct DFD notation and UML diagrams</a:t>
-            </a:r>
-          </a:p>
-          <a:p>
-            <a:pPr lvl="1">
-              <a:spcAft>
-                <a:spcPts val="400"/>
-              </a:spcAft>
-            </a:pPr>
-            <a:r>
-              <a:rPr sz="1600" b="0" dirty="0">
-                <a:solidFill>
-                  <a:srgbClr val="222833"/>
-                </a:solidFill>
-                <a:latin typeface="Cambria"/>
-              </a:rPr>
-              <a:t>Single spacing; each chapter on a new page</a:t>
-            </a:r>
-          </a:p>
-          <a:p>
-            <a:pPr lvl="1">
-              <a:spcAft>
-                <a:spcPts val="400"/>
-              </a:spcAft>
-            </a:pPr>
-            <a:r>
-              <a:rPr sz="1600" b="0" dirty="0">
-                <a:solidFill>
-                  <a:srgbClr val="222833"/>
-                </a:solidFill>
-                <a:latin typeface="Cambria"/>
-              </a:rPr>
-              <a:t>Conclusion, References, Definitions last, unnumbered</a:t>
-            </a:r>
-          </a:p>
-          <a:p>
-            <a:pPr lvl="1">
-              <a:spcAft>
-                <a:spcPts val="400"/>
-              </a:spcAft>
-            </a:pPr>
-            <a:r>
-              <a:rPr sz="1600" b="0" dirty="0">
-                <a:solidFill>
-                  <a:srgbClr val="222833"/>
-                </a:solidFill>
-                <a:latin typeface="Cambria"/>
-              </a:rPr>
-              <a:t>Abstract must be written by the team</a:t>
-            </a:r>
-          </a:p>
-          <a:p>
-            <a:pPr lvl="1">
-              <a:spcAft>
-                <a:spcPts val="400"/>
-              </a:spcAft>
-            </a:pPr>
-            <a:r>
-              <a:rPr sz="1600" b="0" dirty="0">
-                <a:solidFill>
-                  <a:srgbClr val="222833"/>
-                </a:solidFill>
-                <a:latin typeface="Cambria"/>
-              </a:rPr>
-              <a:t>Keep the repository updated for review</a:t>
-            </a:r>
-          </a:p>
-        </p:txBody>
-      </p:sp>
-      <p:sp>
-        <p:nvSpPr>
-          <p:cNvPr id="4" name="Content Placeholder 3"/>
-          <p:cNvSpPr>
-            <a:spLocks noGrp="1"/>
-          </p:cNvSpPr>
-          <p:nvPr>
-            <p:ph sz="half" idx="2"/>
-          </p:nvPr>
-        </p:nvSpPr>
-        <p:spPr/>
-        <p:txBody>
-          <a:bodyPr wrap="square"/>
-          <a:lstStyle/>
-          <a:p>
-            <a:pPr>
-              <a:spcAft>
-                <a:spcPts val="700"/>
-              </a:spcAft>
-            </a:pPr>
-            <a:r>
-              <a:rPr sz="1800" b="1" dirty="0">
-                <a:solidFill>
-                  <a:srgbClr val="2E7D32"/>
-                </a:solidFill>
-                <a:latin typeface="Cambria"/>
-              </a:rPr>
-              <a:t>Action taken</a:t>
-            </a:r>
-          </a:p>
-          <a:p>
-            <a:pPr lvl="1">
-              <a:spcAft>
-                <a:spcPts val="400"/>
-              </a:spcAft>
-            </a:pPr>
-            <a:r>
-              <a:rPr sz="1600" b="0" dirty="0">
-                <a:solidFill>
-                  <a:srgbClr val="222833"/>
-                </a:solidFill>
-                <a:latin typeface="Cambria"/>
-              </a:rPr>
-              <a:t>Evaluation harness built; the measured results are in this deck</a:t>
-            </a:r>
-          </a:p>
-          <a:p>
-            <a:pPr lvl="1">
-              <a:spcAft>
-                <a:spcPts val="400"/>
-              </a:spcAft>
-            </a:pPr>
-            <a:r>
-              <a:rPr sz="1600" b="0" dirty="0">
-                <a:solidFill>
-                  <a:srgbClr val="222833"/>
-                </a:solidFill>
-                <a:latin typeface="Cambria"/>
-              </a:rPr>
-              <a:t>DFDs redrawn in Gane-Sarson notation; 7 UML diagrams</a:t>
-            </a:r>
-          </a:p>
-          <a:p>
-            <a:pPr lvl="1">
-              <a:spcAft>
-                <a:spcPts val="400"/>
-              </a:spcAft>
-            </a:pPr>
-            <a:r>
-              <a:rPr sz="1600" b="0" dirty="0">
-                <a:solidFill>
-                  <a:srgbClr val="222833"/>
-                </a:solidFill>
-                <a:latin typeface="Cambria"/>
-              </a:rPr>
-              <a:t>Document reformatted to the prescribed style</a:t>
-            </a:r>
-          </a:p>
-          <a:p>
-            <a:pPr lvl="1">
-              <a:spcAft>
-                <a:spcPts val="400"/>
-              </a:spcAft>
-            </a:pPr>
-            <a:r>
-              <a:rPr sz="1600" b="0" dirty="0">
-                <a:solidFill>
-                  <a:srgbClr val="222833"/>
-                </a:solidFill>
-                <a:latin typeface="Cambria"/>
-              </a:rPr>
-              <a:t>Sections reordered as instructed</a:t>
-            </a:r>
-          </a:p>
-          <a:p>
-            <a:pPr lvl="1">
-              <a:spcAft>
-                <a:spcPts val="400"/>
-              </a:spcAft>
-            </a:pPr>
-            <a:r>
-              <a:rPr sz="1600" b="0" dirty="0">
-                <a:solidFill>
-                  <a:srgbClr val="222833"/>
-                </a:solidFill>
-                <a:latin typeface="Cambria"/>
-              </a:rPr>
-              <a:t>Abstract written by the team, not generated</a:t>
-            </a:r>
-          </a:p>
-          <a:p>
-            <a:pPr lvl="1">
-              <a:spcAft>
-                <a:spcPts val="400"/>
-              </a:spcAft>
-            </a:pPr>
-            <a:r>
-              <a:rPr sz="1600" b="0" dirty="0">
-                <a:solidFill>
-                  <a:srgbClr val="222833"/>
-                </a:solidFill>
-                <a:latin typeface="Cambria"/>
-              </a:rPr>
-              <a:t>Repository public; continuous integration runs 113 tests on every push</a:t>
-            </a:r>
-            <a:endParaRPr sz="1300" b="0" dirty="0">
-              <a:solidFill>
-                <a:srgbClr val="222833"/>
-              </a:solidFill>
-              <a:latin typeface="Cambria"/>
-            </a:endParaRPr>
-          </a:p>
-        </p:txBody>
-      </p:sp>
-      <p:sp>
-        <p:nvSpPr>
-          <p:cNvPr id="5" name="TextBox 4"/>
-          <p:cNvSpPr txBox="1"/>
-          <p:nvPr/>
-        </p:nvSpPr>
-        <p:spPr>
-          <a:xfrm>
-            <a:off x="18288" y="109728"/>
-            <a:ext cx="8229600" cy="292608"/>
-          </a:xfrm>
-          <a:prstGeom prst="rect">
-            <a:avLst/>
-          </a:prstGeom>
-          <a:noFill/>
-        </p:spPr>
-        <p:txBody>
-          <a:bodyPr wrap="none">
-            <a:spAutoFit/>
-          </a:bodyPr>
-          <a:lstStyle/>
-          <a:p>
-            <a:r>
-              <a:rPr sz="1100" b="1">
-                <a:solidFill>
-                  <a:srgbClr val="028090"/>
-                </a:solidFill>
-                <a:latin typeface="Cambria"/>
-              </a:rPr>
-              <a:t>01 · PROPOSAL REVIEW</a:t>
-            </a:r>
-          </a:p>
-        </p:txBody>
-      </p:sp>
-    </p:spTree>
-  </p:cSld>
-  <p:clrMapOvr>
-    <a:masterClrMapping/>
-  </p:clrMapOvr>
-</p:sld>
-</file>
-
-<file path=ppt/slides/slide30.xml><?xml version="1.0" encoding="utf-8"?>
+<file path=ppt/slides/slide25.xml><?xml version="1.0" encoding="utf-8"?>
 <p:sld xmlns:a="http://schemas.openxmlformats.org/drawingml/2006/main" xmlns:r="http://schemas.openxmlformats.org/officeDocument/2006/relationships" xmlns:p="http://schemas.openxmlformats.org/presentationml/2006/main">
   <p:cSld>
     <p:spTree>
@@ -11915,7 +10900,7 @@
 </p:sld>
 </file>
 
-<file path=ppt/slides/slide31.xml><?xml version="1.0" encoding="utf-8"?>
+<file path=ppt/slides/slide26.xml><?xml version="1.0" encoding="utf-8"?>
 <p:sld xmlns:a="http://schemas.openxmlformats.org/drawingml/2006/main" xmlns:r="http://schemas.openxmlformats.org/officeDocument/2006/relationships" xmlns:p="http://schemas.openxmlformats.org/presentationml/2006/main">
   <p:cSld>
     <p:spTree>
@@ -11990,6 +10975,356 @@
               </a:solidFill>
               <a:latin typeface="Cambria"/>
             </a:endParaRPr>
+          </a:p>
+        </p:txBody>
+      </p:sp>
+    </p:spTree>
+  </p:cSld>
+  <p:clrMapOvr>
+    <a:masterClrMapping/>
+  </p:clrMapOvr>
+</p:sld>
+</file>
+
+<file path=ppt/slides/slide3.xml><?xml version="1.0" encoding="utf-8"?>
+<p:sld xmlns:a="http://schemas.openxmlformats.org/drawingml/2006/main" xmlns:r="http://schemas.openxmlformats.org/officeDocument/2006/relationships" xmlns:p="http://schemas.openxmlformats.org/presentationml/2006/main">
+  <p:cSld>
+    <p:spTree>
+      <p:nvGrpSpPr>
+        <p:cNvPr id="1" name=""/>
+        <p:cNvGrpSpPr/>
+        <p:nvPr/>
+      </p:nvGrpSpPr>
+      <p:grpSpPr>
+        <a:xfrm>
+          <a:off x="0" y="0"/>
+          <a:ext cx="0" cy="0"/>
+          <a:chOff x="0" y="0"/>
+          <a:chExt cx="0" cy="0"/>
+        </a:xfrm>
+      </p:grpSpPr>
+      <p:sp>
+        <p:nvSpPr>
+          <p:cNvPr id="2" name="Title 1"/>
+          <p:cNvSpPr>
+            <a:spLocks noGrp="1"/>
+          </p:cNvSpPr>
+          <p:nvPr>
+            <p:ph type="title"/>
+          </p:nvPr>
+        </p:nvSpPr>
+        <p:spPr/>
+        <p:txBody>
+          <a:bodyPr/>
+          <a:lstStyle/>
+          <a:p>
+            <a:r>
+              <a:rPr sz="2800" b="1">
+                <a:solidFill>
+                  <a:srgbClr val="002060"/>
+                </a:solidFill>
+                <a:latin typeface="Cambria"/>
+              </a:rPr>
+              <a:t>Project Proposal Review — Comments &amp; Actions</a:t>
+            </a:r>
+          </a:p>
+        </p:txBody>
+      </p:sp>
+      <p:sp>
+        <p:nvSpPr>
+          <p:cNvPr id="3" name="Content Placeholder 2"/>
+          <p:cNvSpPr>
+            <a:spLocks noGrp="1"/>
+          </p:cNvSpPr>
+          <p:nvPr>
+            <p:ph sz="half" idx="1"/>
+          </p:nvPr>
+        </p:nvSpPr>
+        <p:spPr/>
+        <p:txBody>
+          <a:bodyPr wrap="square">
+            <a:normAutofit/>
+          </a:bodyPr>
+          <a:lstStyle/>
+          <a:p>
+            <a:pPr>
+              <a:spcAft>
+                <a:spcPts val="700"/>
+              </a:spcAft>
+            </a:pPr>
+            <a:r>
+              <a:rPr sz="1800" b="1" dirty="0">
+                <a:solidFill>
+                  <a:srgbClr val="002060"/>
+                </a:solidFill>
+                <a:latin typeface="Cambria"/>
+              </a:rPr>
+              <a:t>Comments received</a:t>
+            </a:r>
+          </a:p>
+          <a:p>
+            <a:pPr lvl="1">
+              <a:spcAft>
+                <a:spcPts val="400"/>
+              </a:spcAft>
+            </a:pPr>
+            <a:r>
+              <a:rPr sz="1600" b="0" dirty="0">
+                <a:solidFill>
+                  <a:srgbClr val="222833"/>
+                </a:solidFill>
+                <a:latin typeface="Cambria"/>
+              </a:rPr>
+              <a:t>Show measured evidence, not just a working demo</a:t>
+            </a:r>
+          </a:p>
+          <a:p>
+            <a:pPr lvl="1">
+              <a:spcAft>
+                <a:spcPts val="400"/>
+              </a:spcAft>
+            </a:pPr>
+            <a:r>
+              <a:rPr sz="1600" b="0" dirty="0">
+                <a:solidFill>
+                  <a:srgbClr val="222833"/>
+                </a:solidFill>
+                <a:latin typeface="Cambria"/>
+              </a:rPr>
+              <a:t>SRS: correct DFD notation and UML diagrams</a:t>
+            </a:r>
+          </a:p>
+          <a:p>
+            <a:pPr lvl="1">
+              <a:spcAft>
+                <a:spcPts val="400"/>
+              </a:spcAft>
+            </a:pPr>
+            <a:r>
+              <a:rPr sz="1600" b="0" dirty="0">
+                <a:solidFill>
+                  <a:srgbClr val="222833"/>
+                </a:solidFill>
+                <a:latin typeface="Cambria"/>
+              </a:rPr>
+              <a:t>Single spacing; each chapter on a new page</a:t>
+            </a:r>
+          </a:p>
+          <a:p>
+            <a:pPr lvl="1">
+              <a:spcAft>
+                <a:spcPts val="400"/>
+              </a:spcAft>
+            </a:pPr>
+            <a:r>
+              <a:rPr sz="1600" b="0" dirty="0">
+                <a:solidFill>
+                  <a:srgbClr val="222833"/>
+                </a:solidFill>
+                <a:latin typeface="Cambria"/>
+              </a:rPr>
+              <a:t>Conclusion, References, Definitions last, unnumbered</a:t>
+            </a:r>
+          </a:p>
+          <a:p>
+            <a:pPr lvl="1">
+              <a:spcAft>
+                <a:spcPts val="400"/>
+              </a:spcAft>
+            </a:pPr>
+            <a:r>
+              <a:rPr sz="1600" b="0" dirty="0">
+                <a:solidFill>
+                  <a:srgbClr val="222833"/>
+                </a:solidFill>
+                <a:latin typeface="Cambria"/>
+              </a:rPr>
+              <a:t>Abstract must be written by the team</a:t>
+            </a:r>
+          </a:p>
+          <a:p>
+            <a:pPr lvl="1">
+              <a:spcAft>
+                <a:spcPts val="400"/>
+              </a:spcAft>
+            </a:pPr>
+            <a:r>
+              <a:rPr sz="1600" b="0" dirty="0">
+                <a:solidFill>
+                  <a:srgbClr val="222833"/>
+                </a:solidFill>
+                <a:latin typeface="Cambria"/>
+              </a:rPr>
+              <a:t>Keep the repository updated for review</a:t>
+            </a:r>
+          </a:p>
+        </p:txBody>
+      </p:sp>
+      <p:sp>
+        <p:nvSpPr>
+          <p:cNvPr id="4" name="Content Placeholder 3"/>
+          <p:cNvSpPr>
+            <a:spLocks noGrp="1"/>
+          </p:cNvSpPr>
+          <p:nvPr>
+            <p:ph sz="half" idx="2"/>
+          </p:nvPr>
+        </p:nvSpPr>
+        <p:spPr/>
+        <p:txBody>
+          <a:bodyPr wrap="square"/>
+          <a:lstStyle/>
+          <a:p>
+            <a:pPr>
+              <a:spcAft>
+                <a:spcPts val="700"/>
+              </a:spcAft>
+            </a:pPr>
+            <a:r>
+              <a:rPr sz="1800" b="1" dirty="0">
+                <a:solidFill>
+                  <a:srgbClr val="2E7D32"/>
+                </a:solidFill>
+                <a:latin typeface="Cambria"/>
+              </a:rPr>
+              <a:t>Action taken</a:t>
+            </a:r>
+          </a:p>
+          <a:p>
+            <a:pPr lvl="1">
+              <a:spcAft>
+                <a:spcPts val="400"/>
+              </a:spcAft>
+            </a:pPr>
+            <a:r>
+              <a:rPr sz="1600" b="0" dirty="0">
+                <a:solidFill>
+                  <a:srgbClr val="222833"/>
+                </a:solidFill>
+                <a:latin typeface="Cambria"/>
+              </a:rPr>
+              <a:t>Evaluation harness built; the measured results are in this deck</a:t>
+            </a:r>
+          </a:p>
+          <a:p>
+            <a:pPr lvl="1">
+              <a:spcAft>
+                <a:spcPts val="400"/>
+              </a:spcAft>
+            </a:pPr>
+            <a:r>
+              <a:rPr sz="1600" b="0" dirty="0">
+                <a:solidFill>
+                  <a:srgbClr val="222833"/>
+                </a:solidFill>
+                <a:latin typeface="Cambria"/>
+              </a:rPr>
+              <a:t>DFDs redrawn in Gane-Sarson notation; 7 UML diagrams</a:t>
+            </a:r>
+          </a:p>
+          <a:p>
+            <a:pPr lvl="1">
+              <a:spcAft>
+                <a:spcPts val="400"/>
+              </a:spcAft>
+            </a:pPr>
+            <a:r>
+              <a:rPr sz="1600" b="0" dirty="0">
+                <a:solidFill>
+                  <a:srgbClr val="222833"/>
+                </a:solidFill>
+                <a:latin typeface="Cambria"/>
+              </a:rPr>
+              <a:t>Document reformatted to the prescribed style</a:t>
+            </a:r>
+          </a:p>
+          <a:p>
+            <a:pPr lvl="1">
+              <a:spcAft>
+                <a:spcPts val="400"/>
+              </a:spcAft>
+            </a:pPr>
+            <a:r>
+              <a:rPr sz="1600" b="0" dirty="0">
+                <a:solidFill>
+                  <a:srgbClr val="222833"/>
+                </a:solidFill>
+                <a:latin typeface="Cambria"/>
+              </a:rPr>
+              <a:t>Sections reordered as instructed</a:t>
+            </a:r>
+          </a:p>
+          <a:p>
+            <a:pPr lvl="1">
+              <a:spcAft>
+                <a:spcPts val="400"/>
+              </a:spcAft>
+            </a:pPr>
+            <a:r>
+              <a:rPr sz="1600" b="0" dirty="0">
+                <a:solidFill>
+                  <a:srgbClr val="222833"/>
+                </a:solidFill>
+                <a:latin typeface="Cambria"/>
+              </a:rPr>
+              <a:t>Abstract written by the team, not generated</a:t>
+            </a:r>
+          </a:p>
+          <a:p>
+            <a:pPr lvl="1">
+              <a:spcAft>
+                <a:spcPts val="400"/>
+              </a:spcAft>
+            </a:pPr>
+            <a:r>
+              <a:rPr sz="1600" b="0" dirty="0">
+                <a:solidFill>
+                  <a:srgbClr val="222833"/>
+                </a:solidFill>
+                <a:latin typeface="Cambria"/>
+              </a:rPr>
+              <a:t>Repository public; continuous integration runs 113 tests on every push</a:t>
+            </a:r>
+            <a:endParaRPr sz="1300" b="0" dirty="0">
+              <a:solidFill>
+                <a:srgbClr val="222833"/>
+              </a:solidFill>
+              <a:latin typeface="Cambria"/>
+            </a:endParaRPr>
+          </a:p>
+        </p:txBody>
+      </p:sp>
+      <p:sp>
+        <p:nvSpPr>
+          <p:cNvPr id="5" name="TextBox 4"/>
+          <p:cNvSpPr txBox="1"/>
+          <p:nvPr/>
+        </p:nvSpPr>
+        <p:spPr>
+          <a:xfrm>
+            <a:off x="18288" y="109728"/>
+            <a:ext cx="8229600" cy="292608"/>
+          </a:xfrm>
+          <a:prstGeom prst="rect">
+            <a:avLst/>
+          </a:prstGeom>
+          <a:noFill/>
+        </p:spPr>
+        <p:txBody>
+          <a:bodyPr wrap="none">
+            <a:spAutoFit/>
+          </a:bodyPr>
+          <a:lstStyle/>
+          <a:p>
+            <a:r>
+              <a:rPr sz="1100" b="1">
+                <a:solidFill>
+                  <a:srgbClr val="028090"/>
+                </a:solidFill>
+                <a:latin typeface="Cambria"/>
+              </a:rPr>
+              <a:t>01 · PROPOSAL REVIEW</a:t>
+            </a:r>
           </a:p>
         </p:txBody>
       </p:sp>

</xml_diff>

<commit_message>
Remove the challenges and future work slide from the final review deck
The slide held both panels, so Future Work goes with it. The outline entry on
slide 2 is removed and the list renumbered to eight.

Its future-work panel listed "the 7 undetected frauds", which the September
measurement contradicts: recall is 100 per cent and the confusion matrix has
no fraud in the approved row. That figure leaves the deck with the slide.
24 slides to 23.

Co-Authored-By: Claude Opus 5 <noreply@anthropic.com>
</commit_message>
<xml_diff>
--- a/docs/Indus11-Final-Review.pptx
+++ b/docs/Indus11-Final-Review.pptx
@@ -31,7 +31,6 @@
     <p:sldId id="285" r:id="rId37"/>
     <p:sldId id="286" r:id="rId38"/>
     <p:sldId id="269" r:id="rId19"/>
-    <p:sldId id="265" r:id="rId21"/>
     <p:sldId id="267" r:id="rId23"/>
     <p:sldId id="271" r:id="rId24"/>
     <p:sldId id="268" r:id="rId25"/>
@@ -8652,7 +8651,7 @@
                 </a:solidFill>
                 <a:latin typeface="Cambria"/>
               </a:rPr>
-              <a:t>7.  Challenges Faced &amp; Future Work</a:t>
+              <a:t>7.  References</a:t>
             </a:r>
           </a:p>
           <a:p>
@@ -8663,18 +8662,7 @@
                 </a:solidFill>
                 <a:latin typeface="Cambria"/>
               </a:rPr>
-              <a:t>8.  References</a:t>
-            </a:r>
-          </a:p>
-          <a:p>
-            <a:r>
-              <a:rPr sz="2000">
-                <a:solidFill>
-                  <a:srgbClr val="222833"/>
-                </a:solidFill>
-                <a:latin typeface="Cambria"/>
-              </a:rPr>
-              <a:t>9.  Team Contributions</a:t>
+              <a:t>8.  Team Contributions</a:t>
             </a:r>
           </a:p>
         </p:txBody>
@@ -9587,7 +9575,7 @@
                 </a:solidFill>
                 <a:latin typeface="Cambria"/>
               </a:rPr>
-              <a:t>Challenges Faced &amp; Future Work</a:t>
+              <a:t>References</a:t>
             </a:r>
           </a:p>
         </p:txBody>
@@ -9599,7 +9587,7 @@
             <a:spLocks noGrp="1"/>
           </p:cNvSpPr>
           <p:nvPr>
-            <p:ph sz="half" idx="1"/>
+            <p:ph idx="1"/>
           </p:nvPr>
         </p:nvSpPr>
         <p:spPr/>
@@ -9613,127 +9601,15 @@
               </a:spcAft>
             </a:pPr>
             <a:r>
-              <a:rPr sz="1800" b="1">
-                <a:solidFill>
-                  <a:srgbClr val="B26A00"/>
-                </a:solidFill>
-                <a:latin typeface="Cambria"/>
-              </a:rPr>
-              <a:t>Challenges faced</a:t>
-            </a:r>
-          </a:p>
-          <a:p>
-            <a:pPr lvl="1">
-              <a:spcAft>
-                <a:spcPts val="400"/>
-              </a:spcAft>
-            </a:pPr>
-            <a:r>
-              <a:rPr sz="1600" b="0">
-                <a:solidFill>
-                  <a:srgbClr val="222833"/>
-                </a:solidFill>
-                <a:latin typeface="Cambria"/>
-              </a:rPr>
-              <a:t>Coordinating four data stores on one machine</a:t>
-            </a:r>
-          </a:p>
-          <a:p>
-            <a:pPr lvl="1">
-              <a:spcAft>
-                <a:spcPts val="400"/>
-              </a:spcAft>
-            </a:pPr>
-            <a:r>
-              <a:rPr sz="1600" b="0">
-                <a:solidFill>
-                  <a:srgbClr val="222833"/>
-                </a:solidFill>
-                <a:latin typeface="Cambria"/>
-              </a:rPr>
-              <a:t>Keeping model output consistent — solved with a 30-point cap</a:t>
-            </a:r>
-          </a:p>
-          <a:p>
-            <a:pPr lvl="1">
-              <a:spcAft>
-                <a:spcPts val="400"/>
-              </a:spcAft>
-            </a:pPr>
-            <a:r>
-              <a:rPr sz="1600" b="0">
-                <a:solidFill>
-                  <a:srgbClr val="222833"/>
-                </a:solidFill>
-                <a:latin typeface="Cambria"/>
-              </a:rPr>
-              <a:t>Writing Cypher queries for circular money-mule flows</a:t>
-            </a:r>
-          </a:p>
-          <a:p>
-            <a:pPr lvl="1">
-              <a:spcAft>
-                <a:spcPts val="400"/>
-              </a:spcAft>
-            </a:pPr>
-            <a:r>
-              <a:rPr sz="1600" b="0">
-                <a:solidFill>
-                  <a:srgbClr val="222833"/>
-                </a:solidFill>
-                <a:latin typeface="Cambria"/>
-              </a:rPr>
-              <a:t>Two defects the benchmark exposed: a repeated request returned</a:t>
-            </a:r>
-          </a:p>
-          <a:p>
-            <a:pPr lvl="1">
-              <a:spcAft>
-                <a:spcPts val="400"/>
-              </a:spcAft>
-            </a:pPr>
-            <a:r>
-              <a:rPr sz="1600" b="0">
-                <a:solidFill>
-                  <a:srgbClr val="222833"/>
-                </a:solidFill>
-                <a:latin typeface="Cambria"/>
-              </a:rPr>
-              <a:t>a server error, and a parsing fault silently zeroed the AI</a:t>
-            </a:r>
-          </a:p>
-          <a:p>
-            <a:pPr lvl="1">
-              <a:spcAft>
-                <a:spcPts val="400"/>
-              </a:spcAft>
-            </a:pPr>
-            <a:r>
-              <a:rPr sz="1600" b="0">
-                <a:solidFill>
-                  <a:srgbClr val="222833"/>
-                </a:solidFill>
-                <a:latin typeface="Cambria"/>
-              </a:rPr>
-              <a:t>score — both fixed and covered by tests</a:t>
-            </a:r>
-          </a:p>
-        </p:txBody>
-      </p:sp>
-      <p:sp>
-        <p:nvSpPr>
-          <p:cNvPr id="4" name="Content Placeholder 3"/>
-          <p:cNvSpPr>
-            <a:spLocks noGrp="1"/>
-          </p:cNvSpPr>
-          <p:nvPr>
-            <p:ph sz="half" idx="2"/>
-          </p:nvPr>
-        </p:nvSpPr>
-        <p:spPr/>
-        <p:txBody>
-          <a:bodyPr wrap="square"/>
-          <a:lstStyle/>
+              <a:rPr sz="1300" b="0">
+                <a:solidFill>
+                  <a:srgbClr val="222833"/>
+                </a:solidFill>
+                <a:latin typeface="Cambria"/>
+              </a:rPr>
+              <a:t>[1]  Van Vlasselaer, V. et al. (2015). APATE: A novel approach for automated credit card transaction fraud detection using network-based extensions. Decision Support Systems, 75, 38–48.</a:t>
+            </a:r>
+          </a:p>
           <a:p>
             <a:pPr>
               <a:spcAft>
@@ -9741,143 +9617,77 @@
               </a:spcAft>
             </a:pPr>
             <a:r>
-              <a:rPr sz="1800" b="1">
-                <a:solidFill>
-                  <a:srgbClr val="2E7D32"/>
-                </a:solidFill>
-                <a:latin typeface="Cambria"/>
-              </a:rPr>
-              <a:t>Future work</a:t>
-            </a:r>
-          </a:p>
-          <a:p>
-            <a:pPr lvl="1">
+              <a:rPr sz="1300" b="0">
+                <a:solidFill>
+                  <a:srgbClr val="222833"/>
+                </a:solidFill>
+                <a:latin typeface="Cambria"/>
+              </a:rPr>
+              <a:t>[2]  FICO. Falcon Fraud Manager — product documentation. fico.com.</a:t>
+            </a:r>
+          </a:p>
+          <a:p>
+            <a:pPr>
               <a:spcAft>
-                <a:spcPts val="400"/>
+                <a:spcPts val="700"/>
               </a:spcAft>
             </a:pPr>
             <a:r>
-              <a:rPr sz="1600" b="0">
-                <a:solidFill>
-                  <a:srgbClr val="222833"/>
-                </a:solidFill>
-                <a:latin typeface="Cambria"/>
-              </a:rPr>
-              <a:t>Resolve the block-threshold trade-off from recorded scores</a:t>
-            </a:r>
-          </a:p>
-          <a:p>
-            <a:pPr lvl="1">
+              <a:rPr sz="1300" b="0">
+                <a:solidFill>
+                  <a:srgbClr val="222833"/>
+                </a:solidFill>
+                <a:latin typeface="Cambria"/>
+              </a:rPr>
+              <a:t>[3]  Feedzai. RiskOps platform overview. feedzai.com.</a:t>
+            </a:r>
+          </a:p>
+          <a:p>
+            <a:pPr>
               <a:spcAft>
-                <a:spcPts val="400"/>
+                <a:spcPts val="700"/>
               </a:spcAft>
             </a:pPr>
             <a:r>
-              <a:rPr sz="1600" b="0">
-                <a:solidFill>
-                  <a:srgbClr val="222833"/>
-                </a:solidFill>
-                <a:latin typeface="Cambria"/>
-              </a:rPr>
-              <a:t>Add API authentication and request logging</a:t>
-            </a:r>
-          </a:p>
-          <a:p>
-            <a:pPr lvl="1">
+              <a:rPr sz="1300" b="0">
+                <a:solidFill>
+                  <a:srgbClr val="222833"/>
+                </a:solidFill>
+                <a:latin typeface="Cambria"/>
+              </a:rPr>
+              <a:t>[4]  Featurespace. ARIC Risk Hub — adaptive behavioural analytics. featurespace.com.</a:t>
+            </a:r>
+          </a:p>
+          <a:p>
+            <a:pPr>
               <a:spcAft>
-                <a:spcPts val="400"/>
+                <a:spcPts val="700"/>
               </a:spcAft>
             </a:pPr>
             <a:r>
-              <a:rPr sz="1600" b="0">
-                <a:solidFill>
-                  <a:srgbClr val="222833"/>
-                </a:solidFill>
-                <a:latin typeface="Cambria"/>
-              </a:rPr>
-              <a:t>Fraud-ring visualisation on the graph endpoint</a:t>
-            </a:r>
-          </a:p>
-          <a:p>
-            <a:pPr lvl="1">
+              <a:rPr sz="1300" b="0">
+                <a:solidFill>
+                  <a:srgbClr val="222833"/>
+                </a:solidFill>
+                <a:latin typeface="Cambria"/>
+              </a:rPr>
+              <a:t>[5]  Neo4j. Graph algorithms for fraud detection — developer guide. neo4j.com.</a:t>
+            </a:r>
+          </a:p>
+          <a:p>
+            <a:pPr>
               <a:spcAft>
-                <a:spcPts val="400"/>
+                <a:spcPts val="700"/>
               </a:spcAft>
             </a:pPr>
             <a:r>
-              <a:rPr sz="1600" b="0">
-                <a:solidFill>
-                  <a:srgbClr val="222833"/>
-                </a:solidFill>
-                <a:latin typeface="Cambria"/>
-              </a:rPr>
-              <a:t>Investigate the 7 undetected frauds; fan-in / fan-out patterns</a:t>
-            </a:r>
-          </a:p>
-          <a:p>
-            <a:pPr lvl="1">
-              <a:spcAft>
-                <a:spcPts val="400"/>
-              </a:spcAft>
-            </a:pPr>
-            <a:r>
-              <a:rPr sz="1600" b="0">
-                <a:solidFill>
-                  <a:srgbClr val="222833"/>
-                </a:solidFill>
-                <a:latin typeface="Cambria"/>
-              </a:rPr>
-              <a:t>Train a supervised classifier as a fourth signal</a:t>
-            </a:r>
-          </a:p>
-          <a:p>
-            <a:pPr lvl="1">
-              <a:spcAft>
-                <a:spcPts val="400"/>
-              </a:spcAft>
-            </a:pPr>
-            <a:r>
-              <a:rPr sz="1600" b="0">
-                <a:solidFill>
-                  <a:srgbClr val="222833"/>
-                </a:solidFill>
-                <a:latin typeface="Cambria"/>
-              </a:rPr>
-              <a:t>Reduce latency, presently dominated by the local model</a:t>
-            </a:r>
-          </a:p>
-        </p:txBody>
-      </p:sp>
-      <p:sp>
-        <p:nvSpPr>
-          <p:cNvPr id="5" name="TextBox 4"/>
-          <p:cNvSpPr txBox="1"/>
-          <p:nvPr/>
-        </p:nvSpPr>
-        <p:spPr>
-          <a:xfrm>
-            <a:off x="18288" y="109728"/>
-            <a:ext cx="8229600" cy="292608"/>
-          </a:xfrm>
-          <a:prstGeom prst="rect">
-            <a:avLst/>
-          </a:prstGeom>
-          <a:noFill/>
-        </p:spPr>
-        <p:txBody>
-          <a:bodyPr wrap="none">
-            <a:spAutoFit/>
-          </a:bodyPr>
-          <a:lstStyle/>
-          <a:p>
-            <a:r>
-              <a:rPr sz="1100" b="1">
-                <a:solidFill>
-                  <a:srgbClr val="028090"/>
-                </a:solidFill>
-                <a:latin typeface="Cambria"/>
-              </a:rPr>
-              <a:t>07 · CHALLENGES &amp; FUTURE WORK</a:t>
+              <a:rPr sz="1300" b="0">
+                <a:solidFill>
+                  <a:srgbClr val="222833"/>
+                </a:solidFill>
+                <a:latin typeface="Cambria"/>
+              </a:rPr>
+              <a:t>[6]  LangChain &amp; ChromaDB documentation — retrieval-augmented generation.</a:t>
             </a:r>
           </a:p>
         </p:txBody>
@@ -9890,171 +9700,7 @@
 </p:sld>
 </file>
 
-<file path=ppt/slides/slide24.xml><?xml version="1.0" encoding="utf-8"?>
-<p:sld xmlns:a="http://schemas.openxmlformats.org/drawingml/2006/main" xmlns:r="http://schemas.openxmlformats.org/officeDocument/2006/relationships" xmlns:p="http://schemas.openxmlformats.org/presentationml/2006/main">
-  <p:cSld>
-    <p:spTree>
-      <p:nvGrpSpPr>
-        <p:cNvPr id="1" name=""/>
-        <p:cNvGrpSpPr/>
-        <p:nvPr/>
-      </p:nvGrpSpPr>
-      <p:grpSpPr>
-        <a:xfrm>
-          <a:off x="0" y="0"/>
-          <a:ext cx="0" cy="0"/>
-          <a:chOff x="0" y="0"/>
-          <a:chExt cx="0" cy="0"/>
-        </a:xfrm>
-      </p:grpSpPr>
-      <p:sp>
-        <p:nvSpPr>
-          <p:cNvPr id="2" name="Title 1"/>
-          <p:cNvSpPr>
-            <a:spLocks noGrp="1"/>
-          </p:cNvSpPr>
-          <p:nvPr>
-            <p:ph type="title"/>
-          </p:nvPr>
-        </p:nvSpPr>
-        <p:spPr/>
-        <p:txBody>
-          <a:bodyPr/>
-          <a:lstStyle/>
-          <a:p>
-            <a:r>
-              <a:rPr sz="2800" b="1">
-                <a:solidFill>
-                  <a:srgbClr val="002060"/>
-                </a:solidFill>
-                <a:latin typeface="Cambria"/>
-              </a:rPr>
-              <a:t>References</a:t>
-            </a:r>
-          </a:p>
-        </p:txBody>
-      </p:sp>
-      <p:sp>
-        <p:nvSpPr>
-          <p:cNvPr id="3" name="Content Placeholder 2"/>
-          <p:cNvSpPr>
-            <a:spLocks noGrp="1"/>
-          </p:cNvSpPr>
-          <p:nvPr>
-            <p:ph idx="1"/>
-          </p:nvPr>
-        </p:nvSpPr>
-        <p:spPr/>
-        <p:txBody>
-          <a:bodyPr wrap="square"/>
-          <a:lstStyle/>
-          <a:p>
-            <a:pPr>
-              <a:spcAft>
-                <a:spcPts val="700"/>
-              </a:spcAft>
-            </a:pPr>
-            <a:r>
-              <a:rPr sz="1300" b="0">
-                <a:solidFill>
-                  <a:srgbClr val="222833"/>
-                </a:solidFill>
-                <a:latin typeface="Cambria"/>
-              </a:rPr>
-              <a:t>[1]  Van Vlasselaer, V. et al. (2015). APATE: A novel approach for automated credit card transaction fraud detection using network-based extensions. Decision Support Systems, 75, 38–48.</a:t>
-            </a:r>
-          </a:p>
-          <a:p>
-            <a:pPr>
-              <a:spcAft>
-                <a:spcPts val="700"/>
-              </a:spcAft>
-            </a:pPr>
-            <a:r>
-              <a:rPr sz="1300" b="0">
-                <a:solidFill>
-                  <a:srgbClr val="222833"/>
-                </a:solidFill>
-                <a:latin typeface="Cambria"/>
-              </a:rPr>
-              <a:t>[2]  FICO. Falcon Fraud Manager — product documentation. fico.com.</a:t>
-            </a:r>
-          </a:p>
-          <a:p>
-            <a:pPr>
-              <a:spcAft>
-                <a:spcPts val="700"/>
-              </a:spcAft>
-            </a:pPr>
-            <a:r>
-              <a:rPr sz="1300" b="0">
-                <a:solidFill>
-                  <a:srgbClr val="222833"/>
-                </a:solidFill>
-                <a:latin typeface="Cambria"/>
-              </a:rPr>
-              <a:t>[3]  Feedzai. RiskOps platform overview. feedzai.com.</a:t>
-            </a:r>
-          </a:p>
-          <a:p>
-            <a:pPr>
-              <a:spcAft>
-                <a:spcPts val="700"/>
-              </a:spcAft>
-            </a:pPr>
-            <a:r>
-              <a:rPr sz="1300" b="0">
-                <a:solidFill>
-                  <a:srgbClr val="222833"/>
-                </a:solidFill>
-                <a:latin typeface="Cambria"/>
-              </a:rPr>
-              <a:t>[4]  Featurespace. ARIC Risk Hub — adaptive behavioural analytics. featurespace.com.</a:t>
-            </a:r>
-          </a:p>
-          <a:p>
-            <a:pPr>
-              <a:spcAft>
-                <a:spcPts val="700"/>
-              </a:spcAft>
-            </a:pPr>
-            <a:r>
-              <a:rPr sz="1300" b="0">
-                <a:solidFill>
-                  <a:srgbClr val="222833"/>
-                </a:solidFill>
-                <a:latin typeface="Cambria"/>
-              </a:rPr>
-              <a:t>[5]  Neo4j. Graph algorithms for fraud detection — developer guide. neo4j.com.</a:t>
-            </a:r>
-          </a:p>
-          <a:p>
-            <a:pPr>
-              <a:spcAft>
-                <a:spcPts val="700"/>
-              </a:spcAft>
-            </a:pPr>
-            <a:r>
-              <a:rPr sz="1300" b="0">
-                <a:solidFill>
-                  <a:srgbClr val="222833"/>
-                </a:solidFill>
-                <a:latin typeface="Cambria"/>
-              </a:rPr>
-              <a:t>[6]  LangChain &amp; ChromaDB documentation — retrieval-augmented generation.</a:t>
-            </a:r>
-          </a:p>
-        </p:txBody>
-      </p:sp>
-    </p:spTree>
-  </p:cSld>
-  <p:clrMapOvr>
-    <a:masterClrMapping/>
-  </p:clrMapOvr>
-</p:sld>
-</file>
-
-<file path=ppt/slides/slide25.xml><?xml version="1.0" encoding="utf-8"?>
+<file path=ppt/slides/slide23.xml><?xml version="1.0" encoding="utf-8"?>
 <p:sld xmlns:a="http://schemas.openxmlformats.org/drawingml/2006/main" xmlns:r="http://schemas.openxmlformats.org/officeDocument/2006/relationships" xmlns:p="http://schemas.openxmlformats.org/presentationml/2006/main">
   <p:cSld>
     <p:spTree>
@@ -10900,7 +10546,7 @@
 </p:sld>
 </file>
 
-<file path=ppt/slides/slide26.xml><?xml version="1.0" encoding="utf-8"?>
+<file path=ppt/slides/slide24.xml><?xml version="1.0" encoding="utf-8"?>
 <p:sld xmlns:a="http://schemas.openxmlformats.org/drawingml/2006/main" xmlns:r="http://schemas.openxmlformats.org/officeDocument/2006/relationships" xmlns:p="http://schemas.openxmlformats.org/presentationml/2006/main">
   <p:cSld>
     <p:spTree>

</xml_diff>